<commit_message>
style: increase prompt font size to 14pt in slide 17
User prompt:
can you increase the font size of the prompts in slide 17 to 14?  You can use multiple slides.
</commit_message>
<xml_diff>
--- a/papers/sekisssorcar/se_kiss_sorcar_slides.pptx
+++ b/papers/sekisssorcar/se_kiss_sorcar_slides.pptx
@@ -22,6 +22,8 @@
     <p:sldId id="278" r:id="rId29"/>
     <p:sldId id="279" r:id="rId30"/>
     <p:sldId id="270" r:id="rId21"/>
+    <p:sldId id="280" r:id="rId31"/>
+    <p:sldId id="281" r:id="rId32"/>
     <p:sldId id="271" r:id="rId22"/>
     <p:sldId id="272" r:id="rId23"/>
     <p:sldId id="273" r:id="rId24"/>
@@ -8207,7 +8209,7 @@
       <p:grpSpPr/>
       <p:sp>
         <p:nvSpPr>
-          <p:cNvPr id="2" name="Rectangle 1"/>
+          <p:cNvPr id="2" name="TitleAccent"/>
           <p:cNvSpPr/>
           <p:nvPr/>
         </p:nvSpPr>
@@ -8251,7 +8253,7 @@
       </p:sp>
       <p:sp>
         <p:nvSpPr>
-          <p:cNvPr id="3" name="TextBox 2"/>
+          <p:cNvPr id="3" name="Eyebrow"/>
           <p:cNvSpPr txBox="1"/>
           <p:nvPr/>
         </p:nvSpPr>
@@ -8296,7 +8298,7 @@
       </p:sp>
       <p:sp>
         <p:nvSpPr>
-          <p:cNvPr id="4" name="TextBox 3"/>
+          <p:cNvPr id="4" name="Title"/>
           <p:cNvSpPr txBox="1"/>
           <p:nvPr/>
         </p:nvSpPr>
@@ -8341,7 +8343,7 @@
       </p:sp>
       <p:sp>
         <p:nvSpPr>
-          <p:cNvPr id="5" name="TextBox 4"/>
+          <p:cNvPr id="5" name="Subtitle"/>
           <p:cNvSpPr txBox="1"/>
           <p:nvPr/>
         </p:nvSpPr>
@@ -8379,21 +8381,21 @@
                 </a:solidFill>
                 <a:latin typeface="Arial"/>
               </a:rPr>
-              <a:t>Redesigning the git-worktree merge workflow — six consecutive tasks, no file ever opened by hand.</a:t>
-            </a:r>
-          </a:p>
-        </p:txBody>
-      </p:sp>
-      <p:sp>
-        <p:nvSpPr>
-          <p:cNvPr id="6" name="Rectangle 5"/>
+              <a:t>Redesigning the git-worktree merge workflow — six consecutive tasks (1 of 3), no file ever opened by hand.</a:t>
+            </a:r>
+          </a:p>
+        </p:txBody>
+      </p:sp>
+      <p:sp>
+        <p:nvSpPr>
+          <p:cNvPr id="100" name="CardBg1"/>
           <p:cNvSpPr/>
           <p:nvPr/>
         </p:nvSpPr>
         <p:spPr>
           <a:xfrm>
-            <a:off x="822960" y="2600000"/>
-            <a:ext cx="3383280" cy="1850000"/>
+            <a:off x="815847" y="2600000"/>
+            <a:ext cx="5180000" cy="3800000"/>
           </a:xfrm>
           <a:prstGeom prst="rect">
             <a:avLst/>
@@ -8432,14 +8434,14 @@
       </p:sp>
       <p:sp>
         <p:nvSpPr>
-          <p:cNvPr id="7" name="Rectangle 6"/>
+          <p:cNvPr id="101" name="CardAccent1"/>
           <p:cNvSpPr/>
           <p:nvPr/>
         </p:nvSpPr>
         <p:spPr>
           <a:xfrm>
-            <a:off x="822960" y="2600000"/>
-            <a:ext cx="3383280" cy="91440"/>
+            <a:off x="815847" y="2600000"/>
+            <a:ext cx="5180000" cy="91440"/>
           </a:xfrm>
           <a:prstGeom prst="rect">
             <a:avLst/>
@@ -8476,14 +8478,14 @@
       </p:sp>
       <p:sp>
         <p:nvSpPr>
-          <p:cNvPr id="8" name="TextBox 7"/>
+          <p:cNvPr id="102" name="CardHeader1"/>
           <p:cNvSpPr txBox="1"/>
           <p:nvPr/>
         </p:nvSpPr>
         <p:spPr>
           <a:xfrm>
-            <a:off x="1051560" y="2801168"/>
-            <a:ext cx="2926080" cy="457200"/>
+            <a:off x="1044447" y="2801168"/>
+            <a:ext cx="4722800" cy="457200"/>
           </a:xfrm>
           <a:prstGeom prst="rect">
             <a:avLst/>
@@ -8519,14 +8521,14 @@
       </p:sp>
       <p:sp>
         <p:nvSpPr>
-          <p:cNvPr id="9" name="TextBox 8"/>
+          <p:cNvPr id="103" name="CardPrompt1"/>
           <p:cNvSpPr txBox="1"/>
           <p:nvPr/>
         </p:nvSpPr>
         <p:spPr>
           <a:xfrm>
-            <a:off x="1051560" y="3331520"/>
-            <a:ext cx="2926080" cy="1072760"/>
+            <a:off x="1044447" y="3331520"/>
+            <a:ext cx="4722800" cy="2850000"/>
           </a:xfrm>
           <a:prstGeom prst="rect">
             <a:avLst/>
@@ -8534,14 +8536,12 @@
           <a:noFill/>
         </p:spPr>
         <p:txBody>
-          <a:bodyPr wrap="square" anchor="t" lIns="0" rIns="0" tIns="0" bIns="0">
-            <a:spAutoFit/>
-          </a:bodyPr>
+          <a:bodyPr wrap="square" anchor="t" lIns="0" rIns="0" tIns="0" bIns="0"/>
           <a:lstStyle/>
           <a:p>
             <a:pPr algn="l">
               <a:lnSpc>
-                <a:spcPct val="105000"/>
+                <a:spcPct val="110000"/>
               </a:lnSpc>
               <a:spcBef>
                 <a:spcPts val="0"/>
@@ -8551,7 +8551,10 @@
               </a:spcAft>
             </a:pPr>
             <a:r>
-              <a:rPr b="0" sz="1100">
+              <a:rPr b="0" sz="1400">
+                <a:solidFill>
+                  <a:srgbClr val="1A2330"/>
+                </a:solidFill>
                 <a:latin typeface="Courier New"/>
               </a:rPr>
               <a:t>Can you tell me what happens, step by step, with git in worktree_sorcar_agent.py when a task finishes?</a:t>
@@ -8561,14 +8564,14 @@
       </p:sp>
       <p:sp>
         <p:nvSpPr>
-          <p:cNvPr id="10" name="Rectangle 9"/>
+          <p:cNvPr id="110" name="CardBg2"/>
           <p:cNvSpPr/>
           <p:nvPr/>
         </p:nvSpPr>
         <p:spPr>
           <a:xfrm>
-            <a:off x="4407408" y="2600000"/>
-            <a:ext cx="3383280" cy="1850000"/>
+            <a:off x="6195847" y="2600000"/>
+            <a:ext cx="5180000" cy="3800000"/>
           </a:xfrm>
           <a:prstGeom prst="rect">
             <a:avLst/>
@@ -8607,14 +8610,14 @@
       </p:sp>
       <p:sp>
         <p:nvSpPr>
-          <p:cNvPr id="11" name="Rectangle 10"/>
+          <p:cNvPr id="111" name="CardAccent2"/>
           <p:cNvSpPr/>
           <p:nvPr/>
         </p:nvSpPr>
         <p:spPr>
           <a:xfrm>
-            <a:off x="4407408" y="2600000"/>
-            <a:ext cx="3383280" cy="91440"/>
+            <a:off x="6195847" y="2600000"/>
+            <a:ext cx="5180000" cy="91440"/>
           </a:xfrm>
           <a:prstGeom prst="rect">
             <a:avLst/>
@@ -8651,14 +8654,14 @@
       </p:sp>
       <p:sp>
         <p:nvSpPr>
-          <p:cNvPr id="12" name="TextBox 11"/>
+          <p:cNvPr id="112" name="CardHeader2"/>
           <p:cNvSpPr txBox="1"/>
           <p:nvPr/>
         </p:nvSpPr>
         <p:spPr>
           <a:xfrm>
-            <a:off x="4636008" y="2801168"/>
-            <a:ext cx="2926080" cy="457200"/>
+            <a:off x="6424447" y="2801168"/>
+            <a:ext cx="4722800" cy="457200"/>
           </a:xfrm>
           <a:prstGeom prst="rect">
             <a:avLst/>
@@ -8694,14 +8697,14 @@
       </p:sp>
       <p:sp>
         <p:nvSpPr>
-          <p:cNvPr id="13" name="TextBox 12"/>
+          <p:cNvPr id="113" name="CardPrompt2"/>
           <p:cNvSpPr txBox="1"/>
           <p:nvPr/>
         </p:nvSpPr>
         <p:spPr>
           <a:xfrm>
-            <a:off x="4636008" y="3331520"/>
-            <a:ext cx="2926080" cy="1072760"/>
+            <a:off x="6424447" y="3331520"/>
+            <a:ext cx="4722800" cy="2850000"/>
           </a:xfrm>
           <a:prstGeom prst="rect">
             <a:avLst/>
@@ -8709,14 +8712,12 @@
           <a:noFill/>
         </p:spPr>
         <p:txBody>
-          <a:bodyPr wrap="square" anchor="t" lIns="0" rIns="0" tIns="0" bIns="0">
-            <a:spAutoFit/>
-          </a:bodyPr>
+          <a:bodyPr wrap="square" anchor="t" lIns="0" rIns="0" tIns="0" bIns="0"/>
           <a:lstStyle/>
           <a:p>
             <a:pPr algn="l">
               <a:lnSpc>
-                <a:spcPct val="105000"/>
+                <a:spcPct val="110000"/>
               </a:lnSpc>
               <a:spcBef>
                 <a:spcPts val="0"/>
@@ -8726,7 +8727,10 @@
               </a:spcAft>
             </a:pPr>
             <a:r>
-              <a:rPr b="0" sz="900">
+              <a:rPr b="0" sz="1400">
+                <a:solidFill>
+                  <a:srgbClr val="1A2330"/>
+                </a:solidFill>
                 <a:latin typeface="Courier New"/>
               </a:rPr>
               <a:t>Can you change worktree_sorcar_agent.py and the extension so that after the agent finishes its task, it simply asks "Commit and Merge" or "Discard". When "Commit and Merge" is clicked by the user, the agent must commit the changes with a generated commit message, merge the branch with the original branch, and delete the worktree and the branch associated with the worktree. If the user clicks "discard", it must delete the worktree and the branch, and checkout the original branch.</a:t>
@@ -8736,707 +8740,7 @@
       </p:sp>
       <p:sp>
         <p:nvSpPr>
-          <p:cNvPr id="14" name="Rectangle 13"/>
-          <p:cNvSpPr/>
-          <p:nvPr/>
-        </p:nvSpPr>
-        <p:spPr>
-          <a:xfrm>
-            <a:off x="7991856" y="2600000"/>
-            <a:ext cx="3383280" cy="1850000"/>
-          </a:xfrm>
-          <a:prstGeom prst="rect">
-            <a:avLst/>
-          </a:prstGeom>
-          <a:solidFill>
-            <a:srgbClr val="FFFFFF"/>
-          </a:solidFill>
-          <a:ln w="12700">
-            <a:solidFill>
-              <a:srgbClr val="E9E5D8"/>
-            </a:solidFill>
-          </a:ln>
-          <a:effectLst/>
-        </p:spPr>
-        <p:style>
-          <a:lnRef idx="1">
-            <a:schemeClr val="accent1"/>
-          </a:lnRef>
-          <a:fillRef idx="3">
-            <a:schemeClr val="accent1"/>
-          </a:fillRef>
-          <a:effectRef idx="2">
-            <a:schemeClr val="accent1"/>
-          </a:effectRef>
-          <a:fontRef idx="minor">
-            <a:schemeClr val="lt1"/>
-          </a:fontRef>
-        </p:style>
-        <p:txBody>
-          <a:bodyPr rtlCol="0" anchor="ctr"/>
-          <a:lstStyle/>
-          <a:p>
-            <a:pPr algn="ctr"/>
-          </a:p>
-        </p:txBody>
-      </p:sp>
-      <p:sp>
-        <p:nvSpPr>
-          <p:cNvPr id="15" name="Rectangle 14"/>
-          <p:cNvSpPr/>
-          <p:nvPr/>
-        </p:nvSpPr>
-        <p:spPr>
-          <a:xfrm>
-            <a:off x="7991856" y="2600000"/>
-            <a:ext cx="3383280" cy="91440"/>
-          </a:xfrm>
-          <a:prstGeom prst="rect">
-            <a:avLst/>
-          </a:prstGeom>
-          <a:solidFill>
-            <a:srgbClr val="FDB515"/>
-          </a:solidFill>
-          <a:ln>
-            <a:noFill/>
-          </a:ln>
-          <a:effectLst/>
-        </p:spPr>
-        <p:style>
-          <a:lnRef idx="1">
-            <a:schemeClr val="accent1"/>
-          </a:lnRef>
-          <a:fillRef idx="3">
-            <a:schemeClr val="accent1"/>
-          </a:fillRef>
-          <a:effectRef idx="2">
-            <a:schemeClr val="accent1"/>
-          </a:effectRef>
-          <a:fontRef idx="minor">
-            <a:schemeClr val="lt1"/>
-          </a:fontRef>
-        </p:style>
-        <p:txBody>
-          <a:bodyPr rtlCol="0" anchor="ctr"/>
-          <a:lstStyle/>
-          <a:p>
-            <a:pPr algn="ctr"/>
-          </a:p>
-        </p:txBody>
-      </p:sp>
-      <p:sp>
-        <p:nvSpPr>
-          <p:cNvPr id="16" name="TextBox 15"/>
-          <p:cNvSpPr txBox="1"/>
-          <p:nvPr/>
-        </p:nvSpPr>
-        <p:spPr>
-          <a:xfrm>
-            <a:off x="8220456" y="2801168"/>
-            <a:ext cx="2926080" cy="457200"/>
-          </a:xfrm>
-          <a:prstGeom prst="rect">
-            <a:avLst/>
-          </a:prstGeom>
-          <a:noFill/>
-        </p:spPr>
-        <p:txBody>
-          <a:bodyPr wrap="square" anchor="t" lIns="0" rIns="0" tIns="0" bIns="0">
-            <a:spAutoFit/>
-          </a:bodyPr>
-          <a:lstStyle/>
-          <a:p>
-            <a:r>
-              <a:rPr sz="2400" b="1">
-                <a:solidFill>
-                  <a:srgbClr val="FDB515"/>
-                </a:solidFill>
-                <a:latin typeface="Arial"/>
-              </a:rPr>
-              <a:t>3  </a:t>
-            </a:r>
-            <a:r>
-              <a:rPr sz="2000" b="1">
-                <a:solidFill>
-                  <a:srgbClr val="003262"/>
-                </a:solidFill>
-                <a:latin typeface="Arial"/>
-              </a:rPr>
-              <a:t>Diagnose</a:t>
-            </a:r>
-          </a:p>
-        </p:txBody>
-      </p:sp>
-      <p:sp>
-        <p:nvSpPr>
-          <p:cNvPr id="17" name="TextBox 16"/>
-          <p:cNvSpPr txBox="1"/>
-          <p:nvPr/>
-        </p:nvSpPr>
-        <p:spPr>
-          <a:xfrm>
-            <a:off x="8220456" y="3331520"/>
-            <a:ext cx="2926080" cy="1072760"/>
-          </a:xfrm>
-          <a:prstGeom prst="rect">
-            <a:avLst/>
-          </a:prstGeom>
-          <a:noFill/>
-        </p:spPr>
-        <p:txBody>
-          <a:bodyPr wrap="square" anchor="t" lIns="0" rIns="0" tIns="0" bIns="0">
-            <a:spAutoFit/>
-          </a:bodyPr>
-          <a:lstStyle/>
-          <a:p>
-            <a:pPr algn="l">
-              <a:lnSpc>
-                <a:spcPct val="105000"/>
-              </a:lnSpc>
-              <a:spcBef>
-                <a:spcPts val="0"/>
-              </a:spcBef>
-              <a:spcAft>
-                <a:spcPts val="800"/>
-              </a:spcAft>
-            </a:pPr>
-            <a:r>
-              <a:rPr b="0" sz="1100">
-                <a:latin typeface="Courier New"/>
-              </a:rPr>
-              <a:t>After the user presses "Commit and Merge", why do the modified files show up as committed in the original branch?</a:t>
-            </a:r>
-          </a:p>
-        </p:txBody>
-      </p:sp>
-      <p:sp>
-        <p:nvSpPr>
-          <p:cNvPr id="18" name="Rectangle 17"/>
-          <p:cNvSpPr/>
-          <p:nvPr/>
-        </p:nvSpPr>
-        <p:spPr>
-          <a:xfrm>
-            <a:off x="822960" y="4500000"/>
-            <a:ext cx="3383280" cy="1850000"/>
-          </a:xfrm>
-          <a:prstGeom prst="rect">
-            <a:avLst/>
-          </a:prstGeom>
-          <a:solidFill>
-            <a:srgbClr val="FFFFFF"/>
-          </a:solidFill>
-          <a:ln w="12700">
-            <a:solidFill>
-              <a:srgbClr val="E9E5D8"/>
-            </a:solidFill>
-          </a:ln>
-          <a:effectLst/>
-        </p:spPr>
-        <p:style>
-          <a:lnRef idx="1">
-            <a:schemeClr val="accent1"/>
-          </a:lnRef>
-          <a:fillRef idx="3">
-            <a:schemeClr val="accent1"/>
-          </a:fillRef>
-          <a:effectRef idx="2">
-            <a:schemeClr val="accent1"/>
-          </a:effectRef>
-          <a:fontRef idx="minor">
-            <a:schemeClr val="lt1"/>
-          </a:fontRef>
-        </p:style>
-        <p:txBody>
-          <a:bodyPr rtlCol="0" anchor="ctr"/>
-          <a:lstStyle/>
-          <a:p>
-            <a:pPr algn="ctr"/>
-          </a:p>
-        </p:txBody>
-      </p:sp>
-      <p:sp>
-        <p:nvSpPr>
-          <p:cNvPr id="19" name="Rectangle 18"/>
-          <p:cNvSpPr/>
-          <p:nvPr/>
-        </p:nvSpPr>
-        <p:spPr>
-          <a:xfrm>
-            <a:off x="822960" y="4500000"/>
-            <a:ext cx="3383280" cy="91440"/>
-          </a:xfrm>
-          <a:prstGeom prst="rect">
-            <a:avLst/>
-          </a:prstGeom>
-          <a:solidFill>
-            <a:srgbClr val="FDB515"/>
-          </a:solidFill>
-          <a:ln>
-            <a:noFill/>
-          </a:ln>
-          <a:effectLst/>
-        </p:spPr>
-        <p:style>
-          <a:lnRef idx="1">
-            <a:schemeClr val="accent1"/>
-          </a:lnRef>
-          <a:fillRef idx="3">
-            <a:schemeClr val="accent1"/>
-          </a:fillRef>
-          <a:effectRef idx="2">
-            <a:schemeClr val="accent1"/>
-          </a:effectRef>
-          <a:fontRef idx="minor">
-            <a:schemeClr val="lt1"/>
-          </a:fontRef>
-        </p:style>
-        <p:txBody>
-          <a:bodyPr rtlCol="0" anchor="ctr"/>
-          <a:lstStyle/>
-          <a:p>
-            <a:pPr algn="ctr"/>
-          </a:p>
-        </p:txBody>
-      </p:sp>
-      <p:sp>
-        <p:nvSpPr>
-          <p:cNvPr id="20" name="TextBox 19"/>
-          <p:cNvSpPr txBox="1"/>
-          <p:nvPr/>
-        </p:nvSpPr>
-        <p:spPr>
-          <a:xfrm>
-            <a:off x="1051560" y="4701168"/>
-            <a:ext cx="2926080" cy="457200"/>
-          </a:xfrm>
-          <a:prstGeom prst="rect">
-            <a:avLst/>
-          </a:prstGeom>
-          <a:noFill/>
-        </p:spPr>
-        <p:txBody>
-          <a:bodyPr wrap="square" anchor="t" lIns="0" rIns="0" tIns="0" bIns="0">
-            <a:spAutoFit/>
-          </a:bodyPr>
-          <a:lstStyle/>
-          <a:p>
-            <a:r>
-              <a:rPr sz="2400" b="1">
-                <a:solidFill>
-                  <a:srgbClr val="FDB515"/>
-                </a:solidFill>
-                <a:latin typeface="Arial"/>
-              </a:rPr>
-              <a:t>4  </a:t>
-            </a:r>
-            <a:r>
-              <a:rPr sz="2000" b="1">
-                <a:solidFill>
-                  <a:srgbClr val="003262"/>
-                </a:solidFill>
-                <a:latin typeface="Arial"/>
-              </a:rPr>
-              <a:t>Fix</a:t>
-            </a:r>
-          </a:p>
-        </p:txBody>
-      </p:sp>
-      <p:sp>
-        <p:nvSpPr>
-          <p:cNvPr id="21" name="TextBox 20"/>
-          <p:cNvSpPr txBox="1"/>
-          <p:nvPr/>
-        </p:nvSpPr>
-        <p:spPr>
-          <a:xfrm>
-            <a:off x="1051560" y="5231520"/>
-            <a:ext cx="2926080" cy="1072760"/>
-          </a:xfrm>
-          <a:prstGeom prst="rect">
-            <a:avLst/>
-          </a:prstGeom>
-          <a:noFill/>
-        </p:spPr>
-        <p:txBody>
-          <a:bodyPr wrap="square" anchor="t" lIns="0" rIns="0" tIns="0" bIns="0">
-            <a:spAutoFit/>
-          </a:bodyPr>
-          <a:lstStyle/>
-          <a:p>
-            <a:pPr algn="l">
-              <a:lnSpc>
-                <a:spcPct val="105000"/>
-              </a:lnSpc>
-              <a:spcBef>
-                <a:spcPts val="0"/>
-              </a:spcBef>
-              <a:spcAft>
-                <a:spcPts val="800"/>
-              </a:spcAft>
-            </a:pPr>
-            <a:r>
-              <a:rPr b="0" sz="1100">
-                <a:latin typeface="Courier New"/>
-              </a:rPr>
-              <a:t>The review is already happening in the worktree branch. You don't need the user to review the modified and new files in the original branch. Fix it.</a:t>
-            </a:r>
-          </a:p>
-        </p:txBody>
-      </p:sp>
-      <p:sp>
-        <p:nvSpPr>
-          <p:cNvPr id="22" name="Rectangle 21"/>
-          <p:cNvSpPr/>
-          <p:nvPr/>
-        </p:nvSpPr>
-        <p:spPr>
-          <a:xfrm>
-            <a:off x="4407408" y="4500000"/>
-            <a:ext cx="3383280" cy="1850000"/>
-          </a:xfrm>
-          <a:prstGeom prst="rect">
-            <a:avLst/>
-          </a:prstGeom>
-          <a:solidFill>
-            <a:srgbClr val="FFFFFF"/>
-          </a:solidFill>
-          <a:ln w="12700">
-            <a:solidFill>
-              <a:srgbClr val="E9E5D8"/>
-            </a:solidFill>
-          </a:ln>
-          <a:effectLst/>
-        </p:spPr>
-        <p:style>
-          <a:lnRef idx="1">
-            <a:schemeClr val="accent1"/>
-          </a:lnRef>
-          <a:fillRef idx="3">
-            <a:schemeClr val="accent1"/>
-          </a:fillRef>
-          <a:effectRef idx="2">
-            <a:schemeClr val="accent1"/>
-          </a:effectRef>
-          <a:fontRef idx="minor">
-            <a:schemeClr val="lt1"/>
-          </a:fontRef>
-        </p:style>
-        <p:txBody>
-          <a:bodyPr rtlCol="0" anchor="ctr"/>
-          <a:lstStyle/>
-          <a:p>
-            <a:pPr algn="ctr"/>
-          </a:p>
-        </p:txBody>
-      </p:sp>
-      <p:sp>
-        <p:nvSpPr>
-          <p:cNvPr id="23" name="Rectangle 22"/>
-          <p:cNvSpPr/>
-          <p:nvPr/>
-        </p:nvSpPr>
-        <p:spPr>
-          <a:xfrm>
-            <a:off x="4407408" y="4500000"/>
-            <a:ext cx="3383280" cy="91440"/>
-          </a:xfrm>
-          <a:prstGeom prst="rect">
-            <a:avLst/>
-          </a:prstGeom>
-          <a:solidFill>
-            <a:srgbClr val="3B7EA1"/>
-          </a:solidFill>
-          <a:ln>
-            <a:noFill/>
-          </a:ln>
-          <a:effectLst/>
-        </p:spPr>
-        <p:style>
-          <a:lnRef idx="1">
-            <a:schemeClr val="accent1"/>
-          </a:lnRef>
-          <a:fillRef idx="3">
-            <a:schemeClr val="accent1"/>
-          </a:fillRef>
-          <a:effectRef idx="2">
-            <a:schemeClr val="accent1"/>
-          </a:effectRef>
-          <a:fontRef idx="minor">
-            <a:schemeClr val="lt1"/>
-          </a:fontRef>
-        </p:style>
-        <p:txBody>
-          <a:bodyPr rtlCol="0" anchor="ctr"/>
-          <a:lstStyle/>
-          <a:p>
-            <a:pPr algn="ctr"/>
-          </a:p>
-        </p:txBody>
-      </p:sp>
-      <p:sp>
-        <p:nvSpPr>
-          <p:cNvPr id="24" name="TextBox 23"/>
-          <p:cNvSpPr txBox="1"/>
-          <p:nvPr/>
-        </p:nvSpPr>
-        <p:spPr>
-          <a:xfrm>
-            <a:off x="4636008" y="4701168"/>
-            <a:ext cx="2926080" cy="457200"/>
-          </a:xfrm>
-          <a:prstGeom prst="rect">
-            <a:avLst/>
-          </a:prstGeom>
-          <a:noFill/>
-        </p:spPr>
-        <p:txBody>
-          <a:bodyPr wrap="square" anchor="t" lIns="0" rIns="0" tIns="0" bIns="0">
-            <a:spAutoFit/>
-          </a:bodyPr>
-          <a:lstStyle/>
-          <a:p>
-            <a:r>
-              <a:rPr sz="2400" b="1">
-                <a:solidFill>
-                  <a:srgbClr val="FDB515"/>
-                </a:solidFill>
-                <a:latin typeface="Arial"/>
-              </a:rPr>
-              <a:t>5  </a:t>
-            </a:r>
-            <a:r>
-              <a:rPr sz="2000" b="1">
-                <a:solidFill>
-                  <a:srgbClr val="003262"/>
-                </a:solidFill>
-                <a:latin typeface="Arial"/>
-              </a:rPr>
-              <a:t>Audit</a:t>
-            </a:r>
-          </a:p>
-        </p:txBody>
-      </p:sp>
-      <p:sp>
-        <p:nvSpPr>
-          <p:cNvPr id="25" name="TextBox 24"/>
-          <p:cNvSpPr txBox="1"/>
-          <p:nvPr/>
-        </p:nvSpPr>
-        <p:spPr>
-          <a:xfrm>
-            <a:off x="4636008" y="5231520"/>
-            <a:ext cx="2926080" cy="1072760"/>
-          </a:xfrm>
-          <a:prstGeom prst="rect">
-            <a:avLst/>
-          </a:prstGeom>
-          <a:noFill/>
-        </p:spPr>
-        <p:txBody>
-          <a:bodyPr wrap="square" anchor="t" lIns="0" rIns="0" tIns="0" bIns="0">
-            <a:spAutoFit/>
-          </a:bodyPr>
-          <a:lstStyle/>
-          <a:p>
-            <a:pPr algn="l">
-              <a:lnSpc>
-                <a:spcPct val="105000"/>
-              </a:lnSpc>
-              <a:spcBef>
-                <a:spcPts val="0"/>
-              </a:spcBef>
-              <a:spcAft>
-                <a:spcPts val="800"/>
-              </a:spcAft>
-            </a:pPr>
-            <a:r>
-              <a:rPr b="0" sz="1100">
-                <a:latin typeface="Courier New"/>
-              </a:rPr>
-              <a:t>What happens to my uncommitted changes if I start a task while the working tree is dirty and then click "Commit and Merge"?</a:t>
-            </a:r>
-          </a:p>
-        </p:txBody>
-      </p:sp>
-      <p:sp>
-        <p:nvSpPr>
-          <p:cNvPr id="26" name="Rectangle 25"/>
-          <p:cNvSpPr/>
-          <p:nvPr/>
-        </p:nvSpPr>
-        <p:spPr>
-          <a:xfrm>
-            <a:off x="7991856" y="4500000"/>
-            <a:ext cx="3383280" cy="1850000"/>
-          </a:xfrm>
-          <a:prstGeom prst="rect">
-            <a:avLst/>
-          </a:prstGeom>
-          <a:solidFill>
-            <a:srgbClr val="FFFFFF"/>
-          </a:solidFill>
-          <a:ln w="12700">
-            <a:solidFill>
-              <a:srgbClr val="E9E5D8"/>
-            </a:solidFill>
-          </a:ln>
-          <a:effectLst/>
-        </p:spPr>
-        <p:style>
-          <a:lnRef idx="1">
-            <a:schemeClr val="accent1"/>
-          </a:lnRef>
-          <a:fillRef idx="3">
-            <a:schemeClr val="accent1"/>
-          </a:fillRef>
-          <a:effectRef idx="2">
-            <a:schemeClr val="accent1"/>
-          </a:effectRef>
-          <a:fontRef idx="minor">
-            <a:schemeClr val="lt1"/>
-          </a:fontRef>
-        </p:style>
-        <p:txBody>
-          <a:bodyPr rtlCol="0" anchor="ctr"/>
-          <a:lstStyle/>
-          <a:p>
-            <a:pPr algn="ctr"/>
-          </a:p>
-        </p:txBody>
-      </p:sp>
-      <p:sp>
-        <p:nvSpPr>
-          <p:cNvPr id="27" name="Rectangle 26"/>
-          <p:cNvSpPr/>
-          <p:nvPr/>
-        </p:nvSpPr>
-        <p:spPr>
-          <a:xfrm>
-            <a:off x="7991856" y="4500000"/>
-            <a:ext cx="3383280" cy="91440"/>
-          </a:xfrm>
-          <a:prstGeom prst="rect">
-            <a:avLst/>
-          </a:prstGeom>
-          <a:solidFill>
-            <a:srgbClr val="3B7EA1"/>
-          </a:solidFill>
-          <a:ln>
-            <a:noFill/>
-          </a:ln>
-          <a:effectLst/>
-        </p:spPr>
-        <p:style>
-          <a:lnRef idx="1">
-            <a:schemeClr val="accent1"/>
-          </a:lnRef>
-          <a:fillRef idx="3">
-            <a:schemeClr val="accent1"/>
-          </a:fillRef>
-          <a:effectRef idx="2">
-            <a:schemeClr val="accent1"/>
-          </a:effectRef>
-          <a:fontRef idx="minor">
-            <a:schemeClr val="lt1"/>
-          </a:fontRef>
-        </p:style>
-        <p:txBody>
-          <a:bodyPr rtlCol="0" anchor="ctr"/>
-          <a:lstStyle/>
-          <a:p>
-            <a:pPr algn="ctr"/>
-          </a:p>
-        </p:txBody>
-      </p:sp>
-      <p:sp>
-        <p:nvSpPr>
-          <p:cNvPr id="28" name="TextBox 27"/>
-          <p:cNvSpPr txBox="1"/>
-          <p:nvPr/>
-        </p:nvSpPr>
-        <p:spPr>
-          <a:xfrm>
-            <a:off x="8220456" y="4701168"/>
-            <a:ext cx="2926080" cy="457200"/>
-          </a:xfrm>
-          <a:prstGeom prst="rect">
-            <a:avLst/>
-          </a:prstGeom>
-          <a:noFill/>
-        </p:spPr>
-        <p:txBody>
-          <a:bodyPr wrap="square" anchor="t" lIns="0" rIns="0" tIns="0" bIns="0">
-            <a:spAutoFit/>
-          </a:bodyPr>
-          <a:lstStyle/>
-          <a:p>
-            <a:r>
-              <a:rPr sz="2400" b="1">
-                <a:solidFill>
-                  <a:srgbClr val="FDB515"/>
-                </a:solidFill>
-                <a:latin typeface="Arial"/>
-              </a:rPr>
-              <a:t>6  </a:t>
-            </a:r>
-            <a:r>
-              <a:rPr sz="2000" b="1">
-                <a:solidFill>
-                  <a:srgbClr val="003262"/>
-                </a:solidFill>
-                <a:latin typeface="Arial"/>
-              </a:rPr>
-              <a:t>Audit</a:t>
-            </a:r>
-          </a:p>
-        </p:txBody>
-      </p:sp>
-      <p:sp>
-        <p:nvSpPr>
-          <p:cNvPr id="29" name="TextBox 28"/>
-          <p:cNvSpPr txBox="1"/>
-          <p:nvPr/>
-        </p:nvSpPr>
-        <p:spPr>
-          <a:xfrm>
-            <a:off x="8220456" y="5231520"/>
-            <a:ext cx="2926080" cy="1072760"/>
-          </a:xfrm>
-          <a:prstGeom prst="rect">
-            <a:avLst/>
-          </a:prstGeom>
-          <a:noFill/>
-        </p:spPr>
-        <p:txBody>
-          <a:bodyPr wrap="square" anchor="t" lIns="0" rIns="0" tIns="0" bIns="0">
-            <a:spAutoFit/>
-          </a:bodyPr>
-          <a:lstStyle/>
-          <a:p>
-            <a:pPr algn="l">
-              <a:lnSpc>
-                <a:spcPct val="105000"/>
-              </a:lnSpc>
-              <a:spcBef>
-                <a:spcPts val="0"/>
-              </a:spcBef>
-              <a:spcAft>
-                <a:spcPts val="800"/>
-              </a:spcAft>
-            </a:pPr>
-            <a:r>
-              <a:rPr b="0" sz="1100">
-                <a:latin typeface="Courier New"/>
-              </a:rPr>
-              <a:t>What happens if two tabs both press "Commit and Merge" on the same repo at the same time? Can the checkout/merge steps interleave?</a:t>
-            </a:r>
-          </a:p>
-        </p:txBody>
-      </p:sp>
-      <p:sp>
-        <p:nvSpPr>
-          <p:cNvPr id="30" name="Rectangle 29"/>
+          <p:cNvPr id="200" name="FooterRule"/>
           <p:cNvSpPr/>
           <p:nvPr/>
         </p:nvSpPr>
@@ -9480,7 +8784,7 @@
       </p:sp>
       <p:sp>
         <p:nvSpPr>
-          <p:cNvPr id="31" name="TextBox 30"/>
+          <p:cNvPr id="201" name="FooterText"/>
           <p:cNvSpPr txBox="1"/>
           <p:nvPr/>
         </p:nvSpPr>
@@ -9525,7 +8829,7 @@
       </p:sp>
       <p:sp>
         <p:nvSpPr>
-          <p:cNvPr id="32" name="TextBox 31"/>
+          <p:cNvPr id="202" name="PageNumber"/>
           <p:cNvSpPr txBox="1"/>
           <p:nvPr/>
         </p:nvSpPr>
@@ -10799,7 +10103,7 @@
                 </a:solidFill>
                 <a:latin typeface="Arial"/>
               </a:rPr>
-              <a:t>18</a:t>
+              <a:t>20</a:t>
             </a:r>
           </a:p>
         </p:txBody>
@@ -12394,7 +11698,7 @@
                 </a:solidFill>
                 <a:latin typeface="Arial"/>
               </a:rPr>
-              <a:t>19</a:t>
+              <a:t>21</a:t>
             </a:r>
           </a:p>
         </p:txBody>
@@ -13358,7 +12662,7 @@
                 </a:solidFill>
                 <a:latin typeface="Arial"/>
               </a:rPr>
-              <a:t>20</a:t>
+              <a:t>22</a:t>
             </a:r>
           </a:p>
         </p:txBody>
@@ -13860,7 +13164,7 @@
                 </a:solidFill>
                 <a:latin typeface="Arial"/>
               </a:rPr>
-              <a:t>21</a:t>
+              <a:t>23</a:t>
             </a:r>
           </a:p>
         </p:txBody>
@@ -14694,7 +13998,7 @@
                 </a:solidFill>
                 <a:latin typeface="Arial"/>
               </a:rPr>
-              <a:t>22</a:t>
+              <a:t>24</a:t>
             </a:r>
           </a:p>
         </p:txBody>
@@ -15228,7 +14532,7 @@
                 </a:solidFill>
                 <a:latin typeface="Arial"/>
               </a:rPr>
-              <a:t>23</a:t>
+              <a:t>25</a:t>
             </a:r>
           </a:p>
         </p:txBody>
@@ -15477,6 +14781,1388 @@
                 <a:latin typeface="Arial"/>
               </a:rPr>
               <a:t>github.com/ksenxx/kiss_ai</a:t>
+            </a:r>
+          </a:p>
+        </p:txBody>
+      </p:sp>
+    </p:spTree>
+  </p:cSld>
+  <p:clrMapOvr>
+    <a:masterClrMapping/>
+  </p:clrMapOvr>
+</p:sld>
+</file>
+
+<file path=ppt/slides/slide25.xml><?xml version="1.0" encoding="utf-8"?>
+<p:sld xmlns:a="http://schemas.openxmlformats.org/drawingml/2006/main" xmlns:p="http://schemas.openxmlformats.org/presentationml/2006/main" xmlns:r="http://schemas.openxmlformats.org/officeDocument/2006/relationships">
+  <p:cSld>
+    <p:bg>
+      <p:bgPr>
+        <a:solidFill>
+          <a:srgbClr val="F7F5EF"/>
+        </a:solidFill>
+        <a:effectLst/>
+      </p:bgPr>
+    </p:bg>
+    <p:spTree>
+      <p:nvGrpSpPr>
+        <p:cNvPr id="1" name=""/>
+        <p:cNvGrpSpPr/>
+        <p:nvPr/>
+      </p:nvGrpSpPr>
+      <p:grpSpPr/>
+      <p:sp>
+        <p:nvSpPr>
+          <p:cNvPr id="2" name="TitleAccent"/>
+          <p:cNvSpPr/>
+          <p:nvPr/>
+        </p:nvSpPr>
+        <p:spPr>
+          <a:xfrm>
+            <a:off x="457200" y="914400"/>
+            <a:ext cx="146304" cy="502920"/>
+          </a:xfrm>
+          <a:prstGeom prst="rect">
+            <a:avLst/>
+          </a:prstGeom>
+          <a:solidFill>
+            <a:srgbClr val="FDB515"/>
+          </a:solidFill>
+          <a:ln>
+            <a:noFill/>
+          </a:ln>
+          <a:effectLst/>
+        </p:spPr>
+        <p:style>
+          <a:lnRef idx="1">
+            <a:schemeClr val="accent1"/>
+          </a:lnRef>
+          <a:fillRef idx="3">
+            <a:schemeClr val="accent1"/>
+          </a:fillRef>
+          <a:effectRef idx="2">
+            <a:schemeClr val="accent1"/>
+          </a:effectRef>
+          <a:fontRef idx="minor">
+            <a:schemeClr val="lt1"/>
+          </a:fontRef>
+        </p:style>
+        <p:txBody>
+          <a:bodyPr rtlCol="0" anchor="ctr"/>
+          <a:lstStyle/>
+          <a:p>
+            <a:pPr algn="ctr"/>
+          </a:p>
+        </p:txBody>
+      </p:sp>
+      <p:sp>
+        <p:nvSpPr>
+          <p:cNvPr id="3" name="Eyebrow"/>
+          <p:cNvSpPr txBox="1"/>
+          <p:nvPr/>
+        </p:nvSpPr>
+        <p:spPr>
+          <a:xfrm>
+            <a:off x="822960" y="502920"/>
+            <a:ext cx="10515600" cy="365760"/>
+          </a:xfrm>
+          <a:prstGeom prst="rect">
+            <a:avLst/>
+          </a:prstGeom>
+          <a:noFill/>
+        </p:spPr>
+        <p:txBody>
+          <a:bodyPr wrap="square" anchor="t" lIns="0" rIns="0" tIns="0" bIns="0">
+            <a:spAutoFit/>
+          </a:bodyPr>
+          <a:lstStyle/>
+          <a:p>
+            <a:pPr algn="l">
+              <a:lnSpc>
+                <a:spcPct val="100000"/>
+              </a:lnSpc>
+              <a:spcBef>
+                <a:spcPts val="0"/>
+              </a:spcBef>
+              <a:spcAft>
+                <a:spcPts val="800"/>
+              </a:spcAft>
+            </a:pPr>
+            <a:r>
+              <a:rPr sz="1300" b="1" i="0">
+                <a:solidFill>
+                  <a:srgbClr val="C88A00"/>
+                </a:solidFill>
+                <a:latin typeface="Arial"/>
+              </a:rPr>
+              <a:t>C  A  S  E     S  T  U  D  Y</a:t>
+            </a:r>
+          </a:p>
+        </p:txBody>
+      </p:sp>
+      <p:sp>
+        <p:nvSpPr>
+          <p:cNvPr id="4" name="Title"/>
+          <p:cNvSpPr txBox="1"/>
+          <p:nvPr/>
+        </p:nvSpPr>
+        <p:spPr>
+          <a:xfrm>
+            <a:off x="822960" y="868680"/>
+            <a:ext cx="10515600" cy="1280160"/>
+          </a:xfrm>
+          <a:prstGeom prst="rect">
+            <a:avLst/>
+          </a:prstGeom>
+          <a:noFill/>
+        </p:spPr>
+        <p:txBody>
+          <a:bodyPr wrap="square" anchor="t" lIns="0" rIns="0" tIns="0" bIns="0">
+            <a:spAutoFit/>
+          </a:bodyPr>
+          <a:lstStyle/>
+          <a:p>
+            <a:pPr algn="l">
+              <a:lnSpc>
+                <a:spcPct val="100000"/>
+              </a:lnSpc>
+              <a:spcBef>
+                <a:spcPts val="0"/>
+              </a:spcBef>
+              <a:spcAft>
+                <a:spcPts val="800"/>
+              </a:spcAft>
+            </a:pPr>
+            <a:r>
+              <a:rPr sz="3400" b="1" i="0">
+                <a:solidFill>
+                  <a:srgbClr val="003262"/>
+                </a:solidFill>
+                <a:latin typeface="Arial"/>
+              </a:rPr>
+              <a:t>The explain-then-revise loop</a:t>
+            </a:r>
+          </a:p>
+        </p:txBody>
+      </p:sp>
+      <p:sp>
+        <p:nvSpPr>
+          <p:cNvPr id="5" name="Subtitle"/>
+          <p:cNvSpPr txBox="1"/>
+          <p:nvPr/>
+        </p:nvSpPr>
+        <p:spPr>
+          <a:xfrm>
+            <a:off x="822960" y="1783080"/>
+            <a:ext cx="10607040" cy="822960"/>
+          </a:xfrm>
+          <a:prstGeom prst="rect">
+            <a:avLst/>
+          </a:prstGeom>
+          <a:noFill/>
+        </p:spPr>
+        <p:txBody>
+          <a:bodyPr wrap="square" anchor="t" lIns="0" rIns="0" tIns="0" bIns="0">
+            <a:spAutoFit/>
+          </a:bodyPr>
+          <a:lstStyle/>
+          <a:p>
+            <a:pPr algn="l">
+              <a:lnSpc>
+                <a:spcPct val="110000"/>
+              </a:lnSpc>
+              <a:spcBef>
+                <a:spcPts val="0"/>
+              </a:spcBef>
+              <a:spcAft>
+                <a:spcPts val="800"/>
+              </a:spcAft>
+            </a:pPr>
+            <a:r>
+              <a:rPr sz="2100" b="0" i="0">
+                <a:solidFill>
+                  <a:srgbClr val="4A5260"/>
+                </a:solidFill>
+                <a:latin typeface="Arial"/>
+              </a:rPr>
+              <a:t>Redesigning the git-worktree merge workflow — six consecutive tasks (2 of 3), no file ever opened by hand.</a:t>
+            </a:r>
+          </a:p>
+        </p:txBody>
+      </p:sp>
+      <p:sp>
+        <p:nvSpPr>
+          <p:cNvPr id="100" name="CardBg3"/>
+          <p:cNvSpPr/>
+          <p:nvPr/>
+        </p:nvSpPr>
+        <p:spPr>
+          <a:xfrm>
+            <a:off x="815847" y="2600000"/>
+            <a:ext cx="5180000" cy="3800000"/>
+          </a:xfrm>
+          <a:prstGeom prst="rect">
+            <a:avLst/>
+          </a:prstGeom>
+          <a:solidFill>
+            <a:srgbClr val="FFFFFF"/>
+          </a:solidFill>
+          <a:ln w="12700">
+            <a:solidFill>
+              <a:srgbClr val="E9E5D8"/>
+            </a:solidFill>
+          </a:ln>
+          <a:effectLst/>
+        </p:spPr>
+        <p:style>
+          <a:lnRef idx="1">
+            <a:schemeClr val="accent1"/>
+          </a:lnRef>
+          <a:fillRef idx="3">
+            <a:schemeClr val="accent1"/>
+          </a:fillRef>
+          <a:effectRef idx="2">
+            <a:schemeClr val="accent1"/>
+          </a:effectRef>
+          <a:fontRef idx="minor">
+            <a:schemeClr val="lt1"/>
+          </a:fontRef>
+        </p:style>
+        <p:txBody>
+          <a:bodyPr rtlCol="0" anchor="ctr"/>
+          <a:lstStyle/>
+          <a:p>
+            <a:pPr algn="ctr"/>
+          </a:p>
+        </p:txBody>
+      </p:sp>
+      <p:sp>
+        <p:nvSpPr>
+          <p:cNvPr id="101" name="CardAccent3"/>
+          <p:cNvSpPr/>
+          <p:nvPr/>
+        </p:nvSpPr>
+        <p:spPr>
+          <a:xfrm>
+            <a:off x="815847" y="2600000"/>
+            <a:ext cx="5180000" cy="91440"/>
+          </a:xfrm>
+          <a:prstGeom prst="rect">
+            <a:avLst/>
+          </a:prstGeom>
+          <a:solidFill>
+            <a:srgbClr val="FDB515"/>
+          </a:solidFill>
+          <a:ln>
+            <a:noFill/>
+          </a:ln>
+          <a:effectLst/>
+        </p:spPr>
+        <p:style>
+          <a:lnRef idx="1">
+            <a:schemeClr val="accent1"/>
+          </a:lnRef>
+          <a:fillRef idx="3">
+            <a:schemeClr val="accent1"/>
+          </a:fillRef>
+          <a:effectRef idx="2">
+            <a:schemeClr val="accent1"/>
+          </a:effectRef>
+          <a:fontRef idx="minor">
+            <a:schemeClr val="lt1"/>
+          </a:fontRef>
+        </p:style>
+        <p:txBody>
+          <a:bodyPr rtlCol="0" anchor="ctr"/>
+          <a:lstStyle/>
+          <a:p>
+            <a:pPr algn="ctr"/>
+          </a:p>
+        </p:txBody>
+      </p:sp>
+      <p:sp>
+        <p:nvSpPr>
+          <p:cNvPr id="102" name="CardHeader3"/>
+          <p:cNvSpPr txBox="1"/>
+          <p:nvPr/>
+        </p:nvSpPr>
+        <p:spPr>
+          <a:xfrm>
+            <a:off x="1044447" y="2801168"/>
+            <a:ext cx="4722800" cy="457200"/>
+          </a:xfrm>
+          <a:prstGeom prst="rect">
+            <a:avLst/>
+          </a:prstGeom>
+          <a:noFill/>
+        </p:spPr>
+        <p:txBody>
+          <a:bodyPr wrap="square" anchor="t" lIns="0" rIns="0" tIns="0" bIns="0">
+            <a:spAutoFit/>
+          </a:bodyPr>
+          <a:lstStyle/>
+          <a:p>
+            <a:r>
+              <a:rPr sz="2400" b="1">
+                <a:solidFill>
+                  <a:srgbClr val="FDB515"/>
+                </a:solidFill>
+                <a:latin typeface="Arial"/>
+              </a:rPr>
+              <a:t>3  </a:t>
+            </a:r>
+            <a:r>
+              <a:rPr sz="2000" b="1">
+                <a:solidFill>
+                  <a:srgbClr val="003262"/>
+                </a:solidFill>
+                <a:latin typeface="Arial"/>
+              </a:rPr>
+              <a:t>Diagnose</a:t>
+            </a:r>
+          </a:p>
+        </p:txBody>
+      </p:sp>
+      <p:sp>
+        <p:nvSpPr>
+          <p:cNvPr id="103" name="CardPrompt3"/>
+          <p:cNvSpPr txBox="1"/>
+          <p:nvPr/>
+        </p:nvSpPr>
+        <p:spPr>
+          <a:xfrm>
+            <a:off x="1044447" y="3331520"/>
+            <a:ext cx="4722800" cy="2850000"/>
+          </a:xfrm>
+          <a:prstGeom prst="rect">
+            <a:avLst/>
+          </a:prstGeom>
+          <a:noFill/>
+        </p:spPr>
+        <p:txBody>
+          <a:bodyPr wrap="square" anchor="t" lIns="0" rIns="0" tIns="0" bIns="0"/>
+          <a:lstStyle/>
+          <a:p>
+            <a:pPr algn="l">
+              <a:lnSpc>
+                <a:spcPct val="110000"/>
+              </a:lnSpc>
+              <a:spcBef>
+                <a:spcPts val="0"/>
+              </a:spcBef>
+              <a:spcAft>
+                <a:spcPts val="800"/>
+              </a:spcAft>
+            </a:pPr>
+            <a:r>
+              <a:rPr b="0" sz="1400">
+                <a:solidFill>
+                  <a:srgbClr val="1A2330"/>
+                </a:solidFill>
+                <a:latin typeface="Courier New"/>
+              </a:rPr>
+              <a:t>After the user presses "Commit and Merge", why do the modified files show up as committed in the original branch?</a:t>
+            </a:r>
+          </a:p>
+        </p:txBody>
+      </p:sp>
+      <p:sp>
+        <p:nvSpPr>
+          <p:cNvPr id="110" name="CardBg4"/>
+          <p:cNvSpPr/>
+          <p:nvPr/>
+        </p:nvSpPr>
+        <p:spPr>
+          <a:xfrm>
+            <a:off x="6195847" y="2600000"/>
+            <a:ext cx="5180000" cy="3800000"/>
+          </a:xfrm>
+          <a:prstGeom prst="rect">
+            <a:avLst/>
+          </a:prstGeom>
+          <a:solidFill>
+            <a:srgbClr val="FFFFFF"/>
+          </a:solidFill>
+          <a:ln w="12700">
+            <a:solidFill>
+              <a:srgbClr val="E9E5D8"/>
+            </a:solidFill>
+          </a:ln>
+          <a:effectLst/>
+        </p:spPr>
+        <p:style>
+          <a:lnRef idx="1">
+            <a:schemeClr val="accent1"/>
+          </a:lnRef>
+          <a:fillRef idx="3">
+            <a:schemeClr val="accent1"/>
+          </a:fillRef>
+          <a:effectRef idx="2">
+            <a:schemeClr val="accent1"/>
+          </a:effectRef>
+          <a:fontRef idx="minor">
+            <a:schemeClr val="lt1"/>
+          </a:fontRef>
+        </p:style>
+        <p:txBody>
+          <a:bodyPr rtlCol="0" anchor="ctr"/>
+          <a:lstStyle/>
+          <a:p>
+            <a:pPr algn="ctr"/>
+          </a:p>
+        </p:txBody>
+      </p:sp>
+      <p:sp>
+        <p:nvSpPr>
+          <p:cNvPr id="111" name="CardAccent4"/>
+          <p:cNvSpPr/>
+          <p:nvPr/>
+        </p:nvSpPr>
+        <p:spPr>
+          <a:xfrm>
+            <a:off x="6195847" y="2600000"/>
+            <a:ext cx="5180000" cy="91440"/>
+          </a:xfrm>
+          <a:prstGeom prst="rect">
+            <a:avLst/>
+          </a:prstGeom>
+          <a:solidFill>
+            <a:srgbClr val="FDB515"/>
+          </a:solidFill>
+          <a:ln>
+            <a:noFill/>
+          </a:ln>
+          <a:effectLst/>
+        </p:spPr>
+        <p:style>
+          <a:lnRef idx="1">
+            <a:schemeClr val="accent1"/>
+          </a:lnRef>
+          <a:fillRef idx="3">
+            <a:schemeClr val="accent1"/>
+          </a:fillRef>
+          <a:effectRef idx="2">
+            <a:schemeClr val="accent1"/>
+          </a:effectRef>
+          <a:fontRef idx="minor">
+            <a:schemeClr val="lt1"/>
+          </a:fontRef>
+        </p:style>
+        <p:txBody>
+          <a:bodyPr rtlCol="0" anchor="ctr"/>
+          <a:lstStyle/>
+          <a:p>
+            <a:pPr algn="ctr"/>
+          </a:p>
+        </p:txBody>
+      </p:sp>
+      <p:sp>
+        <p:nvSpPr>
+          <p:cNvPr id="112" name="CardHeader4"/>
+          <p:cNvSpPr txBox="1"/>
+          <p:nvPr/>
+        </p:nvSpPr>
+        <p:spPr>
+          <a:xfrm>
+            <a:off x="6424447" y="2801168"/>
+            <a:ext cx="4722800" cy="457200"/>
+          </a:xfrm>
+          <a:prstGeom prst="rect">
+            <a:avLst/>
+          </a:prstGeom>
+          <a:noFill/>
+        </p:spPr>
+        <p:txBody>
+          <a:bodyPr wrap="square" anchor="t" lIns="0" rIns="0" tIns="0" bIns="0">
+            <a:spAutoFit/>
+          </a:bodyPr>
+          <a:lstStyle/>
+          <a:p>
+            <a:r>
+              <a:rPr sz="2400" b="1">
+                <a:solidFill>
+                  <a:srgbClr val="FDB515"/>
+                </a:solidFill>
+                <a:latin typeface="Arial"/>
+              </a:rPr>
+              <a:t>4  </a:t>
+            </a:r>
+            <a:r>
+              <a:rPr sz="2000" b="1">
+                <a:solidFill>
+                  <a:srgbClr val="003262"/>
+                </a:solidFill>
+                <a:latin typeface="Arial"/>
+              </a:rPr>
+              <a:t>Fix</a:t>
+            </a:r>
+          </a:p>
+        </p:txBody>
+      </p:sp>
+      <p:sp>
+        <p:nvSpPr>
+          <p:cNvPr id="113" name="CardPrompt4"/>
+          <p:cNvSpPr txBox="1"/>
+          <p:nvPr/>
+        </p:nvSpPr>
+        <p:spPr>
+          <a:xfrm>
+            <a:off x="6424447" y="3331520"/>
+            <a:ext cx="4722800" cy="2850000"/>
+          </a:xfrm>
+          <a:prstGeom prst="rect">
+            <a:avLst/>
+          </a:prstGeom>
+          <a:noFill/>
+        </p:spPr>
+        <p:txBody>
+          <a:bodyPr wrap="square" anchor="t" lIns="0" rIns="0" tIns="0" bIns="0"/>
+          <a:lstStyle/>
+          <a:p>
+            <a:pPr algn="l">
+              <a:lnSpc>
+                <a:spcPct val="110000"/>
+              </a:lnSpc>
+              <a:spcBef>
+                <a:spcPts val="0"/>
+              </a:spcBef>
+              <a:spcAft>
+                <a:spcPts val="800"/>
+              </a:spcAft>
+            </a:pPr>
+            <a:r>
+              <a:rPr b="0" sz="1400">
+                <a:solidFill>
+                  <a:srgbClr val="1A2330"/>
+                </a:solidFill>
+                <a:latin typeface="Courier New"/>
+              </a:rPr>
+              <a:t>The review is already happening in the worktree branch. You don't need the user to review the modified and new files in the original branch. Fix it.</a:t>
+            </a:r>
+          </a:p>
+        </p:txBody>
+      </p:sp>
+      <p:sp>
+        <p:nvSpPr>
+          <p:cNvPr id="200" name="FooterRule"/>
+          <p:cNvSpPr/>
+          <p:nvPr/>
+        </p:nvSpPr>
+        <p:spPr>
+          <a:xfrm>
+            <a:off x="0" y="6510528"/>
+            <a:ext cx="12191695" cy="27940"/>
+          </a:xfrm>
+          <a:prstGeom prst="rect">
+            <a:avLst/>
+          </a:prstGeom>
+          <a:solidFill>
+            <a:srgbClr val="E9E5D8"/>
+          </a:solidFill>
+          <a:ln>
+            <a:noFill/>
+          </a:ln>
+          <a:effectLst/>
+        </p:spPr>
+        <p:style>
+          <a:lnRef idx="1">
+            <a:schemeClr val="accent1"/>
+          </a:lnRef>
+          <a:fillRef idx="3">
+            <a:schemeClr val="accent1"/>
+          </a:fillRef>
+          <a:effectRef idx="2">
+            <a:schemeClr val="accent1"/>
+          </a:effectRef>
+          <a:fontRef idx="minor">
+            <a:schemeClr val="lt1"/>
+          </a:fontRef>
+        </p:style>
+        <p:txBody>
+          <a:bodyPr rtlCol="0" anchor="ctr"/>
+          <a:lstStyle/>
+          <a:p>
+            <a:pPr algn="ctr"/>
+          </a:p>
+        </p:txBody>
+      </p:sp>
+      <p:sp>
+        <p:nvSpPr>
+          <p:cNvPr id="201" name="FooterText"/>
+          <p:cNvSpPr txBox="1"/>
+          <p:nvPr/>
+        </p:nvSpPr>
+        <p:spPr>
+          <a:xfrm>
+            <a:off x="822960" y="6547104"/>
+            <a:ext cx="8229600" cy="274320"/>
+          </a:xfrm>
+          <a:prstGeom prst="rect">
+            <a:avLst/>
+          </a:prstGeom>
+          <a:noFill/>
+        </p:spPr>
+        <p:txBody>
+          <a:bodyPr wrap="square" anchor="t" lIns="0" rIns="0" tIns="0" bIns="0">
+            <a:spAutoFit/>
+          </a:bodyPr>
+          <a:lstStyle/>
+          <a:p>
+            <a:pPr algn="l">
+              <a:lnSpc>
+                <a:spcPct val="100000"/>
+              </a:lnSpc>
+              <a:spcBef>
+                <a:spcPts val="0"/>
+              </a:spcBef>
+              <a:spcAft>
+                <a:spcPts val="800"/>
+              </a:spcAft>
+            </a:pPr>
+            <a:r>
+              <a:rPr sz="1100" b="0" i="0">
+                <a:solidFill>
+                  <a:srgbClr val="4A5260"/>
+                </a:solidFill>
+                <a:latin typeface="Arial"/>
+              </a:rPr>
+              <a:t>KISS Sorcar  ·  K. Sen, UC Berkeley</a:t>
+            </a:r>
+          </a:p>
+        </p:txBody>
+      </p:sp>
+      <p:sp>
+        <p:nvSpPr>
+          <p:cNvPr id="202" name="PageNumber"/>
+          <p:cNvSpPr txBox="1"/>
+          <p:nvPr/>
+        </p:nvSpPr>
+        <p:spPr>
+          <a:xfrm>
+            <a:off x="10058400" y="6547104"/>
+            <a:ext cx="1307592" cy="274320"/>
+          </a:xfrm>
+          <a:prstGeom prst="rect">
+            <a:avLst/>
+          </a:prstGeom>
+          <a:noFill/>
+        </p:spPr>
+        <p:txBody>
+          <a:bodyPr wrap="square" anchor="t" lIns="0" rIns="0" tIns="0" bIns="0">
+            <a:spAutoFit/>
+          </a:bodyPr>
+          <a:lstStyle/>
+          <a:p>
+            <a:pPr algn="r">
+              <a:lnSpc>
+                <a:spcPct val="100000"/>
+              </a:lnSpc>
+              <a:spcBef>
+                <a:spcPts val="0"/>
+              </a:spcBef>
+              <a:spcAft>
+                <a:spcPts val="800"/>
+              </a:spcAft>
+            </a:pPr>
+            <a:r>
+              <a:rPr sz="1100" b="1" i="0">
+                <a:solidFill>
+                  <a:srgbClr val="C88A00"/>
+                </a:solidFill>
+                <a:latin typeface="Arial"/>
+              </a:rPr>
+              <a:t>18</a:t>
+            </a:r>
+          </a:p>
+        </p:txBody>
+      </p:sp>
+    </p:spTree>
+  </p:cSld>
+  <p:clrMapOvr>
+    <a:masterClrMapping/>
+  </p:clrMapOvr>
+</p:sld>
+</file>
+
+<file path=ppt/slides/slide26.xml><?xml version="1.0" encoding="utf-8"?>
+<p:sld xmlns:a="http://schemas.openxmlformats.org/drawingml/2006/main" xmlns:p="http://schemas.openxmlformats.org/presentationml/2006/main" xmlns:r="http://schemas.openxmlformats.org/officeDocument/2006/relationships">
+  <p:cSld>
+    <p:bg>
+      <p:bgPr>
+        <a:solidFill>
+          <a:srgbClr val="F7F5EF"/>
+        </a:solidFill>
+        <a:effectLst/>
+      </p:bgPr>
+    </p:bg>
+    <p:spTree>
+      <p:nvGrpSpPr>
+        <p:cNvPr id="1" name=""/>
+        <p:cNvGrpSpPr/>
+        <p:nvPr/>
+      </p:nvGrpSpPr>
+      <p:grpSpPr/>
+      <p:sp>
+        <p:nvSpPr>
+          <p:cNvPr id="2" name="TitleAccent"/>
+          <p:cNvSpPr/>
+          <p:nvPr/>
+        </p:nvSpPr>
+        <p:spPr>
+          <a:xfrm>
+            <a:off x="457200" y="914400"/>
+            <a:ext cx="146304" cy="502920"/>
+          </a:xfrm>
+          <a:prstGeom prst="rect">
+            <a:avLst/>
+          </a:prstGeom>
+          <a:solidFill>
+            <a:srgbClr val="FDB515"/>
+          </a:solidFill>
+          <a:ln>
+            <a:noFill/>
+          </a:ln>
+          <a:effectLst/>
+        </p:spPr>
+        <p:style>
+          <a:lnRef idx="1">
+            <a:schemeClr val="accent1"/>
+          </a:lnRef>
+          <a:fillRef idx="3">
+            <a:schemeClr val="accent1"/>
+          </a:fillRef>
+          <a:effectRef idx="2">
+            <a:schemeClr val="accent1"/>
+          </a:effectRef>
+          <a:fontRef idx="minor">
+            <a:schemeClr val="lt1"/>
+          </a:fontRef>
+        </p:style>
+        <p:txBody>
+          <a:bodyPr rtlCol="0" anchor="ctr"/>
+          <a:lstStyle/>
+          <a:p>
+            <a:pPr algn="ctr"/>
+          </a:p>
+        </p:txBody>
+      </p:sp>
+      <p:sp>
+        <p:nvSpPr>
+          <p:cNvPr id="3" name="Eyebrow"/>
+          <p:cNvSpPr txBox="1"/>
+          <p:nvPr/>
+        </p:nvSpPr>
+        <p:spPr>
+          <a:xfrm>
+            <a:off x="822960" y="502920"/>
+            <a:ext cx="10515600" cy="365760"/>
+          </a:xfrm>
+          <a:prstGeom prst="rect">
+            <a:avLst/>
+          </a:prstGeom>
+          <a:noFill/>
+        </p:spPr>
+        <p:txBody>
+          <a:bodyPr wrap="square" anchor="t" lIns="0" rIns="0" tIns="0" bIns="0">
+            <a:spAutoFit/>
+          </a:bodyPr>
+          <a:lstStyle/>
+          <a:p>
+            <a:pPr algn="l">
+              <a:lnSpc>
+                <a:spcPct val="100000"/>
+              </a:lnSpc>
+              <a:spcBef>
+                <a:spcPts val="0"/>
+              </a:spcBef>
+              <a:spcAft>
+                <a:spcPts val="800"/>
+              </a:spcAft>
+            </a:pPr>
+            <a:r>
+              <a:rPr sz="1300" b="1" i="0">
+                <a:solidFill>
+                  <a:srgbClr val="C88A00"/>
+                </a:solidFill>
+                <a:latin typeface="Arial"/>
+              </a:rPr>
+              <a:t>C  A  S  E     S  T  U  D  Y</a:t>
+            </a:r>
+          </a:p>
+        </p:txBody>
+      </p:sp>
+      <p:sp>
+        <p:nvSpPr>
+          <p:cNvPr id="4" name="Title"/>
+          <p:cNvSpPr txBox="1"/>
+          <p:nvPr/>
+        </p:nvSpPr>
+        <p:spPr>
+          <a:xfrm>
+            <a:off x="822960" y="868680"/>
+            <a:ext cx="10515600" cy="1280160"/>
+          </a:xfrm>
+          <a:prstGeom prst="rect">
+            <a:avLst/>
+          </a:prstGeom>
+          <a:noFill/>
+        </p:spPr>
+        <p:txBody>
+          <a:bodyPr wrap="square" anchor="t" lIns="0" rIns="0" tIns="0" bIns="0">
+            <a:spAutoFit/>
+          </a:bodyPr>
+          <a:lstStyle/>
+          <a:p>
+            <a:pPr algn="l">
+              <a:lnSpc>
+                <a:spcPct val="100000"/>
+              </a:lnSpc>
+              <a:spcBef>
+                <a:spcPts val="0"/>
+              </a:spcBef>
+              <a:spcAft>
+                <a:spcPts val="800"/>
+              </a:spcAft>
+            </a:pPr>
+            <a:r>
+              <a:rPr sz="3400" b="1" i="0">
+                <a:solidFill>
+                  <a:srgbClr val="003262"/>
+                </a:solidFill>
+                <a:latin typeface="Arial"/>
+              </a:rPr>
+              <a:t>The explain-then-revise loop</a:t>
+            </a:r>
+          </a:p>
+        </p:txBody>
+      </p:sp>
+      <p:sp>
+        <p:nvSpPr>
+          <p:cNvPr id="5" name="Subtitle"/>
+          <p:cNvSpPr txBox="1"/>
+          <p:nvPr/>
+        </p:nvSpPr>
+        <p:spPr>
+          <a:xfrm>
+            <a:off x="822960" y="1783080"/>
+            <a:ext cx="10607040" cy="822960"/>
+          </a:xfrm>
+          <a:prstGeom prst="rect">
+            <a:avLst/>
+          </a:prstGeom>
+          <a:noFill/>
+        </p:spPr>
+        <p:txBody>
+          <a:bodyPr wrap="square" anchor="t" lIns="0" rIns="0" tIns="0" bIns="0">
+            <a:spAutoFit/>
+          </a:bodyPr>
+          <a:lstStyle/>
+          <a:p>
+            <a:pPr algn="l">
+              <a:lnSpc>
+                <a:spcPct val="110000"/>
+              </a:lnSpc>
+              <a:spcBef>
+                <a:spcPts val="0"/>
+              </a:spcBef>
+              <a:spcAft>
+                <a:spcPts val="800"/>
+              </a:spcAft>
+            </a:pPr>
+            <a:r>
+              <a:rPr sz="2100" b="0" i="0">
+                <a:solidFill>
+                  <a:srgbClr val="4A5260"/>
+                </a:solidFill>
+                <a:latin typeface="Arial"/>
+              </a:rPr>
+              <a:t>Redesigning the git-worktree merge workflow — six consecutive tasks (3 of 3), no file ever opened by hand.</a:t>
+            </a:r>
+          </a:p>
+        </p:txBody>
+      </p:sp>
+      <p:sp>
+        <p:nvSpPr>
+          <p:cNvPr id="100" name="CardBg5"/>
+          <p:cNvSpPr/>
+          <p:nvPr/>
+        </p:nvSpPr>
+        <p:spPr>
+          <a:xfrm>
+            <a:off x="815847" y="2600000"/>
+            <a:ext cx="5180000" cy="3800000"/>
+          </a:xfrm>
+          <a:prstGeom prst="rect">
+            <a:avLst/>
+          </a:prstGeom>
+          <a:solidFill>
+            <a:srgbClr val="FFFFFF"/>
+          </a:solidFill>
+          <a:ln w="12700">
+            <a:solidFill>
+              <a:srgbClr val="E9E5D8"/>
+            </a:solidFill>
+          </a:ln>
+          <a:effectLst/>
+        </p:spPr>
+        <p:style>
+          <a:lnRef idx="1">
+            <a:schemeClr val="accent1"/>
+          </a:lnRef>
+          <a:fillRef idx="3">
+            <a:schemeClr val="accent1"/>
+          </a:fillRef>
+          <a:effectRef idx="2">
+            <a:schemeClr val="accent1"/>
+          </a:effectRef>
+          <a:fontRef idx="minor">
+            <a:schemeClr val="lt1"/>
+          </a:fontRef>
+        </p:style>
+        <p:txBody>
+          <a:bodyPr rtlCol="0" anchor="ctr"/>
+          <a:lstStyle/>
+          <a:p>
+            <a:pPr algn="ctr"/>
+          </a:p>
+        </p:txBody>
+      </p:sp>
+      <p:sp>
+        <p:nvSpPr>
+          <p:cNvPr id="101" name="CardAccent5"/>
+          <p:cNvSpPr/>
+          <p:nvPr/>
+        </p:nvSpPr>
+        <p:spPr>
+          <a:xfrm>
+            <a:off x="815847" y="2600000"/>
+            <a:ext cx="5180000" cy="91440"/>
+          </a:xfrm>
+          <a:prstGeom prst="rect">
+            <a:avLst/>
+          </a:prstGeom>
+          <a:solidFill>
+            <a:srgbClr val="3B7EA1"/>
+          </a:solidFill>
+          <a:ln>
+            <a:noFill/>
+          </a:ln>
+          <a:effectLst/>
+        </p:spPr>
+        <p:style>
+          <a:lnRef idx="1">
+            <a:schemeClr val="accent1"/>
+          </a:lnRef>
+          <a:fillRef idx="3">
+            <a:schemeClr val="accent1"/>
+          </a:fillRef>
+          <a:effectRef idx="2">
+            <a:schemeClr val="accent1"/>
+          </a:effectRef>
+          <a:fontRef idx="minor">
+            <a:schemeClr val="lt1"/>
+          </a:fontRef>
+        </p:style>
+        <p:txBody>
+          <a:bodyPr rtlCol="0" anchor="ctr"/>
+          <a:lstStyle/>
+          <a:p>
+            <a:pPr algn="ctr"/>
+          </a:p>
+        </p:txBody>
+      </p:sp>
+      <p:sp>
+        <p:nvSpPr>
+          <p:cNvPr id="102" name="CardHeader5"/>
+          <p:cNvSpPr txBox="1"/>
+          <p:nvPr/>
+        </p:nvSpPr>
+        <p:spPr>
+          <a:xfrm>
+            <a:off x="1044447" y="2801168"/>
+            <a:ext cx="4722800" cy="457200"/>
+          </a:xfrm>
+          <a:prstGeom prst="rect">
+            <a:avLst/>
+          </a:prstGeom>
+          <a:noFill/>
+        </p:spPr>
+        <p:txBody>
+          <a:bodyPr wrap="square" anchor="t" lIns="0" rIns="0" tIns="0" bIns="0">
+            <a:spAutoFit/>
+          </a:bodyPr>
+          <a:lstStyle/>
+          <a:p>
+            <a:r>
+              <a:rPr sz="2400" b="1">
+                <a:solidFill>
+                  <a:srgbClr val="FDB515"/>
+                </a:solidFill>
+                <a:latin typeface="Arial"/>
+              </a:rPr>
+              <a:t>5  </a:t>
+            </a:r>
+            <a:r>
+              <a:rPr sz="2000" b="1">
+                <a:solidFill>
+                  <a:srgbClr val="003262"/>
+                </a:solidFill>
+                <a:latin typeface="Arial"/>
+              </a:rPr>
+              <a:t>Audit</a:t>
+            </a:r>
+          </a:p>
+        </p:txBody>
+      </p:sp>
+      <p:sp>
+        <p:nvSpPr>
+          <p:cNvPr id="103" name="CardPrompt5"/>
+          <p:cNvSpPr txBox="1"/>
+          <p:nvPr/>
+        </p:nvSpPr>
+        <p:spPr>
+          <a:xfrm>
+            <a:off x="1044447" y="3331520"/>
+            <a:ext cx="4722800" cy="2850000"/>
+          </a:xfrm>
+          <a:prstGeom prst="rect">
+            <a:avLst/>
+          </a:prstGeom>
+          <a:noFill/>
+        </p:spPr>
+        <p:txBody>
+          <a:bodyPr wrap="square" anchor="t" lIns="0" rIns="0" tIns="0" bIns="0"/>
+          <a:lstStyle/>
+          <a:p>
+            <a:pPr algn="l">
+              <a:lnSpc>
+                <a:spcPct val="110000"/>
+              </a:lnSpc>
+              <a:spcBef>
+                <a:spcPts val="0"/>
+              </a:spcBef>
+              <a:spcAft>
+                <a:spcPts val="800"/>
+              </a:spcAft>
+            </a:pPr>
+            <a:r>
+              <a:rPr b="0" sz="1400">
+                <a:solidFill>
+                  <a:srgbClr val="1A2330"/>
+                </a:solidFill>
+                <a:latin typeface="Courier New"/>
+              </a:rPr>
+              <a:t>What happens to my uncommitted changes if I start a task while the working tree is dirty and then click "Commit and Merge"?</a:t>
+            </a:r>
+          </a:p>
+        </p:txBody>
+      </p:sp>
+      <p:sp>
+        <p:nvSpPr>
+          <p:cNvPr id="110" name="CardBg6"/>
+          <p:cNvSpPr/>
+          <p:nvPr/>
+        </p:nvSpPr>
+        <p:spPr>
+          <a:xfrm>
+            <a:off x="6195847" y="2600000"/>
+            <a:ext cx="5180000" cy="3800000"/>
+          </a:xfrm>
+          <a:prstGeom prst="rect">
+            <a:avLst/>
+          </a:prstGeom>
+          <a:solidFill>
+            <a:srgbClr val="FFFFFF"/>
+          </a:solidFill>
+          <a:ln w="12700">
+            <a:solidFill>
+              <a:srgbClr val="E9E5D8"/>
+            </a:solidFill>
+          </a:ln>
+          <a:effectLst/>
+        </p:spPr>
+        <p:style>
+          <a:lnRef idx="1">
+            <a:schemeClr val="accent1"/>
+          </a:lnRef>
+          <a:fillRef idx="3">
+            <a:schemeClr val="accent1"/>
+          </a:fillRef>
+          <a:effectRef idx="2">
+            <a:schemeClr val="accent1"/>
+          </a:effectRef>
+          <a:fontRef idx="minor">
+            <a:schemeClr val="lt1"/>
+          </a:fontRef>
+        </p:style>
+        <p:txBody>
+          <a:bodyPr rtlCol="0" anchor="ctr"/>
+          <a:lstStyle/>
+          <a:p>
+            <a:pPr algn="ctr"/>
+          </a:p>
+        </p:txBody>
+      </p:sp>
+      <p:sp>
+        <p:nvSpPr>
+          <p:cNvPr id="111" name="CardAccent6"/>
+          <p:cNvSpPr/>
+          <p:nvPr/>
+        </p:nvSpPr>
+        <p:spPr>
+          <a:xfrm>
+            <a:off x="6195847" y="2600000"/>
+            <a:ext cx="5180000" cy="91440"/>
+          </a:xfrm>
+          <a:prstGeom prst="rect">
+            <a:avLst/>
+          </a:prstGeom>
+          <a:solidFill>
+            <a:srgbClr val="3B7EA1"/>
+          </a:solidFill>
+          <a:ln>
+            <a:noFill/>
+          </a:ln>
+          <a:effectLst/>
+        </p:spPr>
+        <p:style>
+          <a:lnRef idx="1">
+            <a:schemeClr val="accent1"/>
+          </a:lnRef>
+          <a:fillRef idx="3">
+            <a:schemeClr val="accent1"/>
+          </a:fillRef>
+          <a:effectRef idx="2">
+            <a:schemeClr val="accent1"/>
+          </a:effectRef>
+          <a:fontRef idx="minor">
+            <a:schemeClr val="lt1"/>
+          </a:fontRef>
+        </p:style>
+        <p:txBody>
+          <a:bodyPr rtlCol="0" anchor="ctr"/>
+          <a:lstStyle/>
+          <a:p>
+            <a:pPr algn="ctr"/>
+          </a:p>
+        </p:txBody>
+      </p:sp>
+      <p:sp>
+        <p:nvSpPr>
+          <p:cNvPr id="112" name="CardHeader6"/>
+          <p:cNvSpPr txBox="1"/>
+          <p:nvPr/>
+        </p:nvSpPr>
+        <p:spPr>
+          <a:xfrm>
+            <a:off x="6424447" y="2801168"/>
+            <a:ext cx="4722800" cy="457200"/>
+          </a:xfrm>
+          <a:prstGeom prst="rect">
+            <a:avLst/>
+          </a:prstGeom>
+          <a:noFill/>
+        </p:spPr>
+        <p:txBody>
+          <a:bodyPr wrap="square" anchor="t" lIns="0" rIns="0" tIns="0" bIns="0">
+            <a:spAutoFit/>
+          </a:bodyPr>
+          <a:lstStyle/>
+          <a:p>
+            <a:r>
+              <a:rPr sz="2400" b="1">
+                <a:solidFill>
+                  <a:srgbClr val="FDB515"/>
+                </a:solidFill>
+                <a:latin typeface="Arial"/>
+              </a:rPr>
+              <a:t>6  </a:t>
+            </a:r>
+            <a:r>
+              <a:rPr sz="2000" b="1">
+                <a:solidFill>
+                  <a:srgbClr val="003262"/>
+                </a:solidFill>
+                <a:latin typeface="Arial"/>
+              </a:rPr>
+              <a:t>Audit</a:t>
+            </a:r>
+          </a:p>
+        </p:txBody>
+      </p:sp>
+      <p:sp>
+        <p:nvSpPr>
+          <p:cNvPr id="113" name="CardPrompt6"/>
+          <p:cNvSpPr txBox="1"/>
+          <p:nvPr/>
+        </p:nvSpPr>
+        <p:spPr>
+          <a:xfrm>
+            <a:off x="6424447" y="3331520"/>
+            <a:ext cx="4722800" cy="2850000"/>
+          </a:xfrm>
+          <a:prstGeom prst="rect">
+            <a:avLst/>
+          </a:prstGeom>
+          <a:noFill/>
+        </p:spPr>
+        <p:txBody>
+          <a:bodyPr wrap="square" anchor="t" lIns="0" rIns="0" tIns="0" bIns="0"/>
+          <a:lstStyle/>
+          <a:p>
+            <a:pPr algn="l">
+              <a:lnSpc>
+                <a:spcPct val="110000"/>
+              </a:lnSpc>
+              <a:spcBef>
+                <a:spcPts val="0"/>
+              </a:spcBef>
+              <a:spcAft>
+                <a:spcPts val="800"/>
+              </a:spcAft>
+            </a:pPr>
+            <a:r>
+              <a:rPr b="0" sz="1400">
+                <a:solidFill>
+                  <a:srgbClr val="1A2330"/>
+                </a:solidFill>
+                <a:latin typeface="Courier New"/>
+              </a:rPr>
+              <a:t>What happens if two tabs both press "Commit and Merge" on the same repo at the same time? Can the checkout/merge steps interleave?</a:t>
+            </a:r>
+          </a:p>
+        </p:txBody>
+      </p:sp>
+      <p:sp>
+        <p:nvSpPr>
+          <p:cNvPr id="200" name="FooterRule"/>
+          <p:cNvSpPr/>
+          <p:nvPr/>
+        </p:nvSpPr>
+        <p:spPr>
+          <a:xfrm>
+            <a:off x="0" y="6510528"/>
+            <a:ext cx="12191695" cy="27940"/>
+          </a:xfrm>
+          <a:prstGeom prst="rect">
+            <a:avLst/>
+          </a:prstGeom>
+          <a:solidFill>
+            <a:srgbClr val="E9E5D8"/>
+          </a:solidFill>
+          <a:ln>
+            <a:noFill/>
+          </a:ln>
+          <a:effectLst/>
+        </p:spPr>
+        <p:style>
+          <a:lnRef idx="1">
+            <a:schemeClr val="accent1"/>
+          </a:lnRef>
+          <a:fillRef idx="3">
+            <a:schemeClr val="accent1"/>
+          </a:fillRef>
+          <a:effectRef idx="2">
+            <a:schemeClr val="accent1"/>
+          </a:effectRef>
+          <a:fontRef idx="minor">
+            <a:schemeClr val="lt1"/>
+          </a:fontRef>
+        </p:style>
+        <p:txBody>
+          <a:bodyPr rtlCol="0" anchor="ctr"/>
+          <a:lstStyle/>
+          <a:p>
+            <a:pPr algn="ctr"/>
+          </a:p>
+        </p:txBody>
+      </p:sp>
+      <p:sp>
+        <p:nvSpPr>
+          <p:cNvPr id="201" name="FooterText"/>
+          <p:cNvSpPr txBox="1"/>
+          <p:nvPr/>
+        </p:nvSpPr>
+        <p:spPr>
+          <a:xfrm>
+            <a:off x="822960" y="6547104"/>
+            <a:ext cx="8229600" cy="274320"/>
+          </a:xfrm>
+          <a:prstGeom prst="rect">
+            <a:avLst/>
+          </a:prstGeom>
+          <a:noFill/>
+        </p:spPr>
+        <p:txBody>
+          <a:bodyPr wrap="square" anchor="t" lIns="0" rIns="0" tIns="0" bIns="0">
+            <a:spAutoFit/>
+          </a:bodyPr>
+          <a:lstStyle/>
+          <a:p>
+            <a:pPr algn="l">
+              <a:lnSpc>
+                <a:spcPct val="100000"/>
+              </a:lnSpc>
+              <a:spcBef>
+                <a:spcPts val="0"/>
+              </a:spcBef>
+              <a:spcAft>
+                <a:spcPts val="800"/>
+              </a:spcAft>
+            </a:pPr>
+            <a:r>
+              <a:rPr sz="1100" b="0" i="0">
+                <a:solidFill>
+                  <a:srgbClr val="4A5260"/>
+                </a:solidFill>
+                <a:latin typeface="Arial"/>
+              </a:rPr>
+              <a:t>KISS Sorcar  ·  K. Sen, UC Berkeley</a:t>
+            </a:r>
+          </a:p>
+        </p:txBody>
+      </p:sp>
+      <p:sp>
+        <p:nvSpPr>
+          <p:cNvPr id="202" name="PageNumber"/>
+          <p:cNvSpPr txBox="1"/>
+          <p:nvPr/>
+        </p:nvSpPr>
+        <p:spPr>
+          <a:xfrm>
+            <a:off x="10058400" y="6547104"/>
+            <a:ext cx="1307592" cy="274320"/>
+          </a:xfrm>
+          <a:prstGeom prst="rect">
+            <a:avLst/>
+          </a:prstGeom>
+          <a:noFill/>
+        </p:spPr>
+        <p:txBody>
+          <a:bodyPr wrap="square" anchor="t" lIns="0" rIns="0" tIns="0" bIns="0">
+            <a:spAutoFit/>
+          </a:bodyPr>
+          <a:lstStyle/>
+          <a:p>
+            <a:pPr algn="r">
+              <a:lnSpc>
+                <a:spcPct val="100000"/>
+              </a:lnSpc>
+              <a:spcBef>
+                <a:spcPts val="0"/>
+              </a:spcBef>
+              <a:spcAft>
+                <a:spcPts val="800"/>
+              </a:spcAft>
+            </a:pPr>
+            <a:r>
+              <a:rPr sz="1100" b="1" i="0">
+                <a:solidFill>
+                  <a:srgbClr val="C88A00"/>
+                </a:solidFill>
+                <a:latin typeface="Arial"/>
+              </a:rPr>
+              <a:t>19</a:t>
             </a:r>
           </a:p>
         </p:txBody>

</xml_diff>

<commit_message>
docs: update SE-KISS-SorCaR slides to reflect paper revisions
User prompt:
can you update the slides at ./papers/sekisssorcar/se_kiss_sorcar_slides.pptx based on the updated paper at ./papers/sekisssorcar/se_kiss_sorcar.tex ?  Build the paper.
</commit_message>
<xml_diff>
--- a/papers/sekisssorcar/se_kiss_sorcar_slides.pptx
+++ b/papers/sekisssorcar/se_kiss_sorcar_slides.pptx
@@ -18,6 +18,8 @@
     <p:sldId id="267" r:id="rId12"/>
     <p:sldId id="268" r:id="rId13"/>
     <p:sldId id="269" r:id="rId14"/>
+    <p:sldId id="316" r:id="rId33"/>
+    <p:sldId id="317" r:id="rId34"/>
     <p:sldId id="278" r:id="rId15"/>
     <p:sldId id="279" r:id="rId16"/>
     <p:sldId id="270" r:id="rId17"/>
@@ -16309,7 +16311,7 @@
                 </a:solidFill>
                 <a:latin typeface="Arial"/>
               </a:rPr>
-              <a:t>Seven patterns emerged from 44 days of building KISS Sorcar with itself.</a:t>
+              <a:t>Nine patterns emerged from 44 days of building KISS Sorcar with itself.</a:t>
             </a:r>
           </a:p>
           <a:p>
@@ -16905,6 +16907,1058 @@
 </p:sld>
 </file>
 
+<file path=ppt/slides/slide28.xml><?xml version="1.0" encoding="utf-8"?>
+<p:sld xmlns:a="http://schemas.openxmlformats.org/drawingml/2006/main" xmlns:p="http://schemas.openxmlformats.org/presentationml/2006/main" xmlns:r="http://schemas.openxmlformats.org/officeDocument/2006/relationships">
+  <p:cSld>
+    <p:spTree>
+      <p:nvGrpSpPr>
+        <p:cNvPr id="1" name=""/>
+        <p:cNvGrpSpPr/>
+        <p:nvPr/>
+      </p:nvGrpSpPr>
+      <p:grpSpPr/>
+      <p:sp>
+        <p:nvSpPr>
+          <p:cNvPr id="2" name="Rectangle 1"/>
+          <p:cNvSpPr/>
+          <p:nvPr/>
+        </p:nvSpPr>
+        <p:spPr>
+          <a:xfrm>
+            <a:off x="457200" y="914400"/>
+            <a:ext cx="146304" cy="502920"/>
+          </a:xfrm>
+          <a:prstGeom prst="rect">
+            <a:avLst/>
+          </a:prstGeom>
+          <a:solidFill>
+            <a:srgbClr val="FDB515"/>
+          </a:solidFill>
+          <a:ln>
+            <a:noFill/>
+          </a:ln>
+          <a:effectLst/>
+        </p:spPr>
+        <p:style>
+          <a:lnRef idx="1">
+            <a:schemeClr val="accent1"/>
+          </a:lnRef>
+          <a:fillRef idx="3">
+            <a:schemeClr val="accent1"/>
+          </a:fillRef>
+          <a:effectRef idx="2">
+            <a:schemeClr val="accent1"/>
+          </a:effectRef>
+          <a:fontRef idx="minor">
+            <a:schemeClr val="lt1"/>
+          </a:fontRef>
+        </p:style>
+        <p:txBody>
+          <a:bodyPr rtlCol="0" anchor="ctr"/>
+          <a:lstStyle/>
+          <a:p>
+            <a:pPr algn="ctr"/>
+            <a:endParaRPr/>
+          </a:p>
+        </p:txBody>
+      </p:sp>
+      <p:sp>
+        <p:nvSpPr>
+          <p:cNvPr id="3" name="TextBox 2"/>
+          <p:cNvSpPr txBox="1"/>
+          <p:nvPr/>
+        </p:nvSpPr>
+        <p:spPr>
+          <a:xfrm>
+            <a:off x="822960" y="502920"/>
+            <a:ext cx="10515600" cy="365760"/>
+          </a:xfrm>
+          <a:prstGeom prst="rect">
+            <a:avLst/>
+          </a:prstGeom>
+          <a:noFill/>
+        </p:spPr>
+        <p:txBody>
+          <a:bodyPr wrap="square" lIns="0" tIns="0" rIns="0" bIns="0" anchor="t">
+            <a:spAutoFit/>
+          </a:bodyPr>
+          <a:lstStyle/>
+          <a:p>
+            <a:pPr algn="l">
+              <a:lnSpc>
+                <a:spcPct val="100000"/>
+              </a:lnSpc>
+              <a:spcBef>
+                <a:spcPts val="0"/>
+              </a:spcBef>
+              <a:spcAft>
+                <a:spcPts val="800"/>
+              </a:spcAft>
+            </a:pPr>
+            <a:r>
+              <a:rPr sz="1300" b="1" i="0">
+                <a:solidFill>
+                  <a:srgbClr val="C88A00"/>
+                </a:solidFill>
+                <a:latin typeface="Arial"/>
+              </a:rPr>
+              <a:t>P  A  T  T  E  R  N     8</a:t>
+            </a:r>
+          </a:p>
+        </p:txBody>
+      </p:sp>
+      <p:sp>
+        <p:nvSpPr>
+          <p:cNvPr id="4" name="TextBox 3"/>
+          <p:cNvSpPr txBox="1"/>
+          <p:nvPr/>
+        </p:nvSpPr>
+        <p:spPr>
+          <a:xfrm>
+            <a:off x="822960" y="868680"/>
+            <a:ext cx="10515600" cy="1280160"/>
+          </a:xfrm>
+          <a:prstGeom prst="rect">
+            <a:avLst/>
+          </a:prstGeom>
+          <a:noFill/>
+        </p:spPr>
+        <p:txBody>
+          <a:bodyPr wrap="square" lIns="0" tIns="0" rIns="0" bIns="0" anchor="t">
+            <a:spAutoFit/>
+          </a:bodyPr>
+          <a:lstStyle/>
+          <a:p>
+            <a:pPr algn="l">
+              <a:lnSpc>
+                <a:spcPct val="100000"/>
+              </a:lnSpc>
+              <a:spcBef>
+                <a:spcPts val="0"/>
+              </a:spcBef>
+              <a:spcAft>
+                <a:spcPts val="800"/>
+              </a:spcAft>
+            </a:pPr>
+            <a:r>
+              <a:rPr sz="3400" b="1" i="0">
+                <a:solidFill>
+                  <a:srgbClr val="003262"/>
+                </a:solidFill>
+                <a:latin typeface="Arial"/>
+              </a:rPr>
+              <a:t>Invariant specification and repair</a:t>
+            </a:r>
+          </a:p>
+        </p:txBody>
+      </p:sp>
+      <p:sp>
+        <p:nvSpPr>
+          <p:cNvPr id="5" name="TextBox 4"/>
+          <p:cNvSpPr txBox="1"/>
+          <p:nvPr/>
+        </p:nvSpPr>
+        <p:spPr>
+          <a:xfrm>
+            <a:off x="822960" y="1783080"/>
+            <a:ext cx="10607040" cy="822960"/>
+          </a:xfrm>
+          <a:prstGeom prst="rect">
+            <a:avLst/>
+          </a:prstGeom>
+          <a:noFill/>
+        </p:spPr>
+        <p:txBody>
+          <a:bodyPr wrap="square" lIns="0" tIns="0" rIns="0" bIns="0" anchor="t">
+            <a:spAutoFit/>
+          </a:bodyPr>
+          <a:lstStyle/>
+          <a:p>
+            <a:pPr algn="l">
+              <a:lnSpc>
+                <a:spcPct val="112000"/>
+              </a:lnSpc>
+              <a:spcBef>
+                <a:spcPts val="0"/>
+              </a:spcBef>
+              <a:spcAft>
+                <a:spcPts val="800"/>
+              </a:spcAft>
+            </a:pPr>
+            <a:r>
+              <a:rPr sz="2100" b="0" i="0">
+                <a:solidFill>
+                  <a:srgbClr val="4A5260"/>
+                </a:solidFill>
+                <a:latin typeface="Arial"/>
+              </a:rPr>
+              <a:t>State a user-visible invariant in one sentence, reproduce any violation with an end-to-end test before touching code, then split implementer and reviewer across two vendors.</a:t>
+            </a:r>
+          </a:p>
+        </p:txBody>
+      </p:sp>
+      <p:sp>
+        <p:nvSpPr>
+          <p:cNvPr id="6" name="TextBox 5"/>
+          <p:cNvSpPr txBox="1"/>
+          <p:nvPr/>
+        </p:nvSpPr>
+        <p:spPr>
+          <a:xfrm>
+            <a:off x="822960" y="2743200"/>
+            <a:ext cx="6126480" cy="3383280"/>
+          </a:xfrm>
+          <a:prstGeom prst="rect">
+            <a:avLst/>
+          </a:prstGeom>
+          <a:noFill/>
+        </p:spPr>
+        <p:txBody>
+          <a:bodyPr wrap="square" lIns="0" tIns="0" rIns="0" bIns="0" anchor="t">
+            <a:spAutoFit/>
+          </a:bodyPr>
+          <a:lstStyle/>
+          <a:p>
+            <a:pPr algn="l">
+              <a:lnSpc>
+                <a:spcPct val="106000"/>
+              </a:lnSpc>
+              <a:spcAft>
+                <a:spcPts val="1400"/>
+              </a:spcAft>
+            </a:pPr>
+            <a:r>
+              <a:rPr sz="1900" b="1">
+                <a:solidFill>
+                  <a:srgbClr val="FDB515"/>
+                </a:solidFill>
+                <a:latin typeface="Arial"/>
+              </a:rPr>
+              <a:t>—  </a:t>
+            </a:r>
+            <a:r>
+              <a:rPr sz="1900" b="1">
+                <a:solidFill>
+                  <a:srgbClr val="003262"/>
+                </a:solidFill>
+                <a:latin typeface="Arial"/>
+              </a:rPr>
+              <a:t>Five-line template:  </a:t>
+            </a:r>
+            <a:r>
+              <a:rPr sz="1900">
+                <a:solidFill>
+                  <a:srgbClr val="1A1F2B"/>
+                </a:solidFill>
+                <a:latin typeface="Arial"/>
+              </a:rPr>
+              <a:t>X MUST hold → reproduce with an integration test → fix → model A codes → model B (other vendor) reviews.</a:t>
+            </a:r>
+          </a:p>
+          <a:p>
+            <a:pPr algn="l">
+              <a:lnSpc>
+                <a:spcPct val="106000"/>
+              </a:lnSpc>
+              <a:spcAft>
+                <a:spcPts val="1400"/>
+              </a:spcAft>
+            </a:pPr>
+            <a:r>
+              <a:rPr sz="1900" b="1">
+                <a:solidFill>
+                  <a:srgbClr val="FDB515"/>
+                </a:solidFill>
+                <a:latin typeface="Arial"/>
+              </a:rPr>
+              <a:t>—  </a:t>
+            </a:r>
+            <a:r>
+              <a:rPr sz="1900" b="1">
+                <a:solidFill>
+                  <a:srgbClr val="003262"/>
+                </a:solidFill>
+                <a:latin typeface="Arial"/>
+              </a:rPr>
+              <a:t>Test before fix:  </a:t>
+            </a:r>
+            <a:r>
+              <a:rPr sz="1900">
+                <a:solidFill>
+                  <a:srgbClr val="1A1F2B"/>
+                </a:solidFill>
+                <a:latin typeface="Arial"/>
+              </a:rPr>
+              <a:t>the failing-then-passing end-to-end test is an artifact the reviewer can refute independently and stays as a regression guard.</a:t>
+            </a:r>
+          </a:p>
+          <a:p>
+            <a:pPr algn="l">
+              <a:lnSpc>
+                <a:spcPct val="106000"/>
+              </a:lnSpc>
+              <a:spcAft>
+                <a:spcPts val="1400"/>
+              </a:spcAft>
+            </a:pPr>
+            <a:r>
+              <a:rPr sz="1900" b="1">
+                <a:solidFill>
+                  <a:srgbClr val="FDB515"/>
+                </a:solidFill>
+                <a:latin typeface="Arial"/>
+              </a:rPr>
+              <a:t>—  </a:t>
+            </a:r>
+            <a:r>
+              <a:rPr sz="1900" b="1">
+                <a:solidFill>
+                  <a:srgbClr val="003262"/>
+                </a:solidFill>
+                <a:latin typeface="Arial"/>
+              </a:rPr>
+              <a:t>Cross-vendor reviewer:  </a:t>
+            </a:r>
+            <a:r>
+              <a:rPr sz="1900">
+                <a:solidFill>
+                  <a:srgbClr val="1A1F2B"/>
+                </a:solidFill>
+                <a:latin typeface="Arial"/>
+              </a:rPr>
+              <a:t>different training distributions catch library-internal blind spots a single model would systematically miss.</a:t>
+            </a:r>
+          </a:p>
+          <a:p>
+            <a:pPr algn="l">
+              <a:lnSpc>
+                <a:spcPct val="106000"/>
+              </a:lnSpc>
+              <a:spcAft>
+                <a:spcPts val="1400"/>
+              </a:spcAft>
+            </a:pPr>
+            <a:r>
+              <a:rPr sz="1900" b="1">
+                <a:solidFill>
+                  <a:srgbClr val="FDB515"/>
+                </a:solidFill>
+                <a:latin typeface="Arial"/>
+              </a:rPr>
+              <a:t>—  </a:t>
+            </a:r>
+            <a:r>
+              <a:rPr sz="1900" b="1">
+                <a:solidFill>
+                  <a:srgbClr val="003262"/>
+                </a:solidFill>
+                <a:latin typeface="Arial"/>
+              </a:rPr>
+              <a:t>Generality:  </a:t>
+            </a:r>
+            <a:r>
+              <a:rPr sz="1900">
+                <a:solidFill>
+                  <a:srgbClr val="1A1F2B"/>
+                </a:solidFill>
+                <a:latin typeface="Arial"/>
+              </a:rPr>
+              <a:t>CLI multi-line input + word wrap, bash-output routing, stale notifications, Read-tool highlighting, temp-file location rule.</a:t>
+            </a:r>
+          </a:p>
+        </p:txBody>
+      </p:sp>
+      <p:sp>
+        <p:nvSpPr>
+          <p:cNvPr id="7" name="Rectangle 6"/>
+          <p:cNvSpPr/>
+          <p:nvPr/>
+        </p:nvSpPr>
+        <p:spPr>
+          <a:xfrm>
+            <a:off x="7178040" y="2743200"/>
+            <a:ext cx="4160520" cy="3200400"/>
+          </a:xfrm>
+          <a:prstGeom prst="rect">
+            <a:avLst/>
+          </a:prstGeom>
+          <a:solidFill>
+            <a:srgbClr val="003262"/>
+          </a:solidFill>
+          <a:ln>
+            <a:noFill/>
+          </a:ln>
+          <a:effectLst/>
+        </p:spPr>
+        <p:style>
+          <a:lnRef idx="1">
+            <a:schemeClr val="accent1"/>
+          </a:lnRef>
+          <a:fillRef idx="3">
+            <a:schemeClr val="accent1"/>
+          </a:fillRef>
+          <a:effectRef idx="2">
+            <a:schemeClr val="accent1"/>
+          </a:effectRef>
+          <a:fontRef idx="minor">
+            <a:schemeClr val="lt1"/>
+          </a:fontRef>
+        </p:style>
+        <p:txBody>
+          <a:bodyPr rtlCol="0" anchor="ctr"/>
+          <a:lstStyle/>
+          <a:p>
+            <a:pPr algn="ctr"/>
+            <a:endParaRPr/>
+          </a:p>
+        </p:txBody>
+      </p:sp>
+      <p:sp>
+        <p:nvSpPr>
+          <p:cNvPr id="8" name="Rectangle 7"/>
+          <p:cNvSpPr/>
+          <p:nvPr/>
+        </p:nvSpPr>
+        <p:spPr>
+          <a:xfrm>
+            <a:off x="7178040" y="2743200"/>
+            <a:ext cx="4160520" cy="109728"/>
+          </a:xfrm>
+          <a:prstGeom prst="rect">
+            <a:avLst/>
+          </a:prstGeom>
+          <a:solidFill>
+            <a:srgbClr val="FDB515"/>
+          </a:solidFill>
+          <a:ln>
+            <a:noFill/>
+          </a:ln>
+          <a:effectLst/>
+        </p:spPr>
+        <p:style>
+          <a:lnRef idx="1">
+            <a:schemeClr val="accent1"/>
+          </a:lnRef>
+          <a:fillRef idx="3">
+            <a:schemeClr val="accent1"/>
+          </a:fillRef>
+          <a:effectRef idx="2">
+            <a:schemeClr val="accent1"/>
+          </a:effectRef>
+          <a:fontRef idx="minor">
+            <a:schemeClr val="lt1"/>
+          </a:fontRef>
+        </p:style>
+        <p:txBody>
+          <a:bodyPr rtlCol="0" anchor="ctr"/>
+          <a:lstStyle/>
+          <a:p>
+            <a:pPr algn="ctr"/>
+            <a:endParaRPr/>
+          </a:p>
+        </p:txBody>
+      </p:sp>
+      <p:sp>
+        <p:nvSpPr>
+          <p:cNvPr id="9" name="TextBox 8"/>
+          <p:cNvSpPr txBox="1"/>
+          <p:nvPr/>
+        </p:nvSpPr>
+        <p:spPr>
+          <a:xfrm>
+            <a:off x="7498080" y="3063240"/>
+            <a:ext cx="3520440" cy="2651760"/>
+          </a:xfrm>
+          <a:prstGeom prst="rect">
+            <a:avLst/>
+          </a:prstGeom>
+          <a:noFill/>
+        </p:spPr>
+        <p:txBody>
+          <a:bodyPr wrap="square" lIns="0" tIns="0" rIns="0" bIns="0" anchor="ctr">
+            <a:spAutoFit/>
+          </a:bodyPr>
+          <a:lstStyle/>
+          <a:p>
+            <a:pPr algn="l">
+              <a:lnSpc>
+                <a:spcPct val="100000"/>
+              </a:lnSpc>
+              <a:spcBef>
+                <a:spcPts val="0"/>
+              </a:spcBef>
+              <a:spcAft>
+                <a:spcPts val="1200"/>
+              </a:spcAft>
+            </a:pPr>
+            <a:r>
+              <a:rPr sz="1300" b="1" i="0">
+                <a:solidFill>
+                  <a:srgbClr val="FDB515"/>
+                </a:solidFill>
+                <a:latin typeface="Arial"/>
+              </a:rPr>
+              <a:t>From the log</a:t>
+            </a:r>
+          </a:p>
+          <a:p>
+            <a:pPr algn="l">
+              <a:lnSpc>
+                <a:spcPct val="112000"/>
+              </a:lnSpc>
+              <a:spcBef>
+                <a:spcPts val="0"/>
+              </a:spcBef>
+              <a:spcAft>
+                <a:spcPts val="800"/>
+              </a:spcAft>
+            </a:pPr>
+            <a:r>
+              <a:rPr sz="1900" b="0" i="1">
+                <a:solidFill>
+                  <a:srgbClr val="FFFFFF"/>
+                </a:solidFill>
+                <a:latin typeface="Arial"/>
+              </a:rPr>
+              <a:t>“…the user MUST be able to enter multi-line inputs… Reproduce with an integration test, then fix. Use claude-opus-4-7 for code; gpt-5.5 (not codex) for review.”</a:t>
+            </a:r>
+          </a:p>
+        </p:txBody>
+      </p:sp>
+    </p:spTree>
+  </p:cSld>
+  <p:clrMapOvr>
+    <a:masterClrMapping/>
+  </p:clrMapOvr>
+</p:sld>
+</file>
+
+<file path=ppt/slides/slide29.xml><?xml version="1.0" encoding="utf-8"?>
+<p:sld xmlns:a="http://schemas.openxmlformats.org/drawingml/2006/main" xmlns:p="http://schemas.openxmlformats.org/presentationml/2006/main" xmlns:r="http://schemas.openxmlformats.org/officeDocument/2006/relationships">
+  <p:cSld>
+    <p:spTree>
+      <p:nvGrpSpPr>
+        <p:cNvPr id="1" name=""/>
+        <p:cNvGrpSpPr/>
+        <p:nvPr/>
+      </p:nvGrpSpPr>
+      <p:grpSpPr/>
+      <p:sp>
+        <p:nvSpPr>
+          <p:cNvPr id="2" name="Rectangle 1"/>
+          <p:cNvSpPr/>
+          <p:nvPr/>
+        </p:nvSpPr>
+        <p:spPr>
+          <a:xfrm>
+            <a:off x="457200" y="914400"/>
+            <a:ext cx="146304" cy="502920"/>
+          </a:xfrm>
+          <a:prstGeom prst="rect">
+            <a:avLst/>
+          </a:prstGeom>
+          <a:solidFill>
+            <a:srgbClr val="FDB515"/>
+          </a:solidFill>
+          <a:ln>
+            <a:noFill/>
+          </a:ln>
+          <a:effectLst/>
+        </p:spPr>
+        <p:style>
+          <a:lnRef idx="1">
+            <a:schemeClr val="accent1"/>
+          </a:lnRef>
+          <a:fillRef idx="3">
+            <a:schemeClr val="accent1"/>
+          </a:fillRef>
+          <a:effectRef idx="2">
+            <a:schemeClr val="accent1"/>
+          </a:effectRef>
+          <a:fontRef idx="minor">
+            <a:schemeClr val="lt1"/>
+          </a:fontRef>
+        </p:style>
+        <p:txBody>
+          <a:bodyPr rtlCol="0" anchor="ctr"/>
+          <a:lstStyle/>
+          <a:p>
+            <a:pPr algn="ctr"/>
+            <a:endParaRPr/>
+          </a:p>
+        </p:txBody>
+      </p:sp>
+      <p:sp>
+        <p:nvSpPr>
+          <p:cNvPr id="3" name="TextBox 2"/>
+          <p:cNvSpPr txBox="1"/>
+          <p:nvPr/>
+        </p:nvSpPr>
+        <p:spPr>
+          <a:xfrm>
+            <a:off x="822960" y="502920"/>
+            <a:ext cx="10515600" cy="365760"/>
+          </a:xfrm>
+          <a:prstGeom prst="rect">
+            <a:avLst/>
+          </a:prstGeom>
+          <a:noFill/>
+        </p:spPr>
+        <p:txBody>
+          <a:bodyPr wrap="square" lIns="0" tIns="0" rIns="0" bIns="0" anchor="t">
+            <a:spAutoFit/>
+          </a:bodyPr>
+          <a:lstStyle/>
+          <a:p>
+            <a:pPr algn="l">
+              <a:lnSpc>
+                <a:spcPct val="100000"/>
+              </a:lnSpc>
+              <a:spcBef>
+                <a:spcPts val="0"/>
+              </a:spcBef>
+              <a:spcAft>
+                <a:spcPts val="800"/>
+              </a:spcAft>
+            </a:pPr>
+            <a:r>
+              <a:rPr sz="1300" b="1" i="0">
+                <a:solidFill>
+                  <a:srgbClr val="C88A00"/>
+                </a:solidFill>
+                <a:latin typeface="Arial"/>
+              </a:rPr>
+              <a:t>P  A  T  T  E  R  N     9</a:t>
+            </a:r>
+          </a:p>
+        </p:txBody>
+      </p:sp>
+      <p:sp>
+        <p:nvSpPr>
+          <p:cNvPr id="4" name="TextBox 3"/>
+          <p:cNvSpPr txBox="1"/>
+          <p:nvPr/>
+        </p:nvSpPr>
+        <p:spPr>
+          <a:xfrm>
+            <a:off x="822960" y="868680"/>
+            <a:ext cx="10515600" cy="1280160"/>
+          </a:xfrm>
+          <a:prstGeom prst="rect">
+            <a:avLst/>
+          </a:prstGeom>
+          <a:noFill/>
+        </p:spPr>
+        <p:txBody>
+          <a:bodyPr wrap="square" lIns="0" tIns="0" rIns="0" bIns="0" anchor="t">
+            <a:spAutoFit/>
+          </a:bodyPr>
+          <a:lstStyle/>
+          <a:p>
+            <a:pPr algn="l">
+              <a:lnSpc>
+                <a:spcPct val="100000"/>
+              </a:lnSpc>
+              <a:spcBef>
+                <a:spcPts val="0"/>
+              </a:spcBef>
+              <a:spcAft>
+                <a:spcPts val="800"/>
+              </a:spcAft>
+            </a:pPr>
+            <a:r>
+              <a:rPr sz="3400" b="1" i="0">
+                <a:solidFill>
+                  <a:srgbClr val="003262"/>
+                </a:solidFill>
+                <a:latin typeface="Arial"/>
+              </a:rPr>
+              <a:t>Cross-model iterative review</a:t>
+            </a:r>
+          </a:p>
+        </p:txBody>
+      </p:sp>
+      <p:sp>
+        <p:nvSpPr>
+          <p:cNvPr id="5" name="TextBox 4"/>
+          <p:cNvSpPr txBox="1"/>
+          <p:nvPr/>
+        </p:nvSpPr>
+        <p:spPr>
+          <a:xfrm>
+            <a:off x="822960" y="1783080"/>
+            <a:ext cx="10607040" cy="822960"/>
+          </a:xfrm>
+          <a:prstGeom prst="rect">
+            <a:avLst/>
+          </a:prstGeom>
+          <a:noFill/>
+        </p:spPr>
+        <p:txBody>
+          <a:bodyPr wrap="square" lIns="0" tIns="0" rIns="0" bIns="0" anchor="t">
+            <a:spAutoFit/>
+          </a:bodyPr>
+          <a:lstStyle/>
+          <a:p>
+            <a:pPr algn="l">
+              <a:lnSpc>
+                <a:spcPct val="112000"/>
+              </a:lnSpc>
+              <a:spcBef>
+                <a:spcPts val="0"/>
+              </a:spcBef>
+              <a:spcAft>
+                <a:spcPts val="800"/>
+              </a:spcAft>
+            </a:pPr>
+            <a:r>
+              <a:rPr sz="2100" b="0" i="0">
+                <a:solidFill>
+                  <a:srgbClr val="4A5260"/>
+                </a:solidFill>
+                <a:latin typeface="Arial"/>
+              </a:rPr>
+              <a:t>set_model lets one agent swap weights mid-task — primary writes code, a different vendor's model audits, repeat until clean.</a:t>
+            </a:r>
+          </a:p>
+        </p:txBody>
+      </p:sp>
+      <p:sp>
+        <p:nvSpPr>
+          <p:cNvPr id="6" name="TextBox 5"/>
+          <p:cNvSpPr txBox="1"/>
+          <p:nvPr/>
+        </p:nvSpPr>
+        <p:spPr>
+          <a:xfrm>
+            <a:off x="822960" y="2743200"/>
+            <a:ext cx="6126480" cy="3383280"/>
+          </a:xfrm>
+          <a:prstGeom prst="rect">
+            <a:avLst/>
+          </a:prstGeom>
+          <a:noFill/>
+        </p:spPr>
+        <p:txBody>
+          <a:bodyPr wrap="square" lIns="0" tIns="0" rIns="0" bIns="0" anchor="t">
+            <a:spAutoFit/>
+          </a:bodyPr>
+          <a:lstStyle/>
+          <a:p>
+            <a:pPr algn="l">
+              <a:lnSpc>
+                <a:spcPct val="106000"/>
+              </a:lnSpc>
+              <a:spcAft>
+                <a:spcPts val="1400"/>
+              </a:spcAft>
+            </a:pPr>
+            <a:r>
+              <a:rPr sz="1900" b="1">
+                <a:solidFill>
+                  <a:srgbClr val="FDB515"/>
+                </a:solidFill>
+                <a:latin typeface="Arial"/>
+              </a:rPr>
+              <a:t>—  </a:t>
+            </a:r>
+            <a:r>
+              <a:rPr sz="1900" b="1">
+                <a:solidFill>
+                  <a:srgbClr val="003262"/>
+                </a:solidFill>
+                <a:latin typeface="Arial"/>
+              </a:rPr>
+              <a:t>set_model tool:  </a:t>
+            </a:r>
+            <a:r>
+              <a:rPr sz="1900">
+                <a:solidFill>
+                  <a:srgbClr val="1A1F2B"/>
+                </a:solidFill>
+                <a:latin typeface="Arial"/>
+              </a:rPr>
+              <a:t>copies conversation history and cumulative budget; rebuilds the tools schema in the new vendor's dialect; persists across turns.</a:t>
+            </a:r>
+          </a:p>
+          <a:p>
+            <a:pPr algn="l">
+              <a:lnSpc>
+                <a:spcPct val="106000"/>
+              </a:lnSpc>
+              <a:spcAft>
+                <a:spcPts val="1400"/>
+              </a:spcAft>
+            </a:pPr>
+            <a:r>
+              <a:rPr sz="1900" b="1">
+                <a:solidFill>
+                  <a:srgbClr val="FDB515"/>
+                </a:solidFill>
+                <a:latin typeface="Arial"/>
+              </a:rPr>
+              <a:t>—  </a:t>
+            </a:r>
+            <a:r>
+              <a:rPr sz="1900" b="1">
+                <a:solidFill>
+                  <a:srgbClr val="003262"/>
+                </a:solidFill>
+                <a:latin typeface="Arial"/>
+              </a:rPr>
+              <a:t>Three idiomatic uses:  </a:t>
+            </a:r>
+            <a:r>
+              <a:rPr sz="1900">
+                <a:solidFill>
+                  <a:srgbClr val="1A1F2B"/>
+                </a:solidFill>
+                <a:latin typeface="Arial"/>
+              </a:rPr>
+              <a:t>scout-then-edit (cheap → strong); generate-then-review (vendor swap); cost-aware long-loop (frontier only at decisions).</a:t>
+            </a:r>
+          </a:p>
+          <a:p>
+            <a:pPr algn="l">
+              <a:lnSpc>
+                <a:spcPct val="106000"/>
+              </a:lnSpc>
+              <a:spcAft>
+                <a:spcPts val="1400"/>
+              </a:spcAft>
+            </a:pPr>
+            <a:r>
+              <a:rPr sz="1900" b="1">
+                <a:solidFill>
+                  <a:srgbClr val="FDB515"/>
+                </a:solidFill>
+                <a:latin typeface="Arial"/>
+              </a:rPr>
+              <a:t>—  </a:t>
+            </a:r>
+            <a:r>
+              <a:rPr sz="1900" b="1">
+                <a:solidFill>
+                  <a:srgbClr val="003262"/>
+                </a:solidFill>
+                <a:latin typeface="Arial"/>
+              </a:rPr>
+              <a:t>Ensemble disagreement:  </a:t>
+            </a:r>
+            <a:r>
+              <a:rPr sz="1900">
+                <a:solidFill>
+                  <a:srgbClr val="1A1F2B"/>
+                </a:solidFill>
+                <a:latin typeface="Arial"/>
+              </a:rPr>
+              <a:t>off-by-ones, missed call sites, and stale imports that a single model blesses are caught by a model trained on a different mixture.</a:t>
+            </a:r>
+          </a:p>
+          <a:p>
+            <a:pPr algn="l">
+              <a:lnSpc>
+                <a:spcPct val="106000"/>
+              </a:lnSpc>
+              <a:spcAft>
+                <a:spcPts val="1400"/>
+              </a:spcAft>
+            </a:pPr>
+            <a:r>
+              <a:rPr sz="1900" b="1">
+                <a:solidFill>
+                  <a:srgbClr val="FDB515"/>
+                </a:solidFill>
+                <a:latin typeface="Arial"/>
+              </a:rPr>
+              <a:t>—  </a:t>
+            </a:r>
+            <a:r>
+              <a:rPr sz="1900" b="1">
+                <a:solidFill>
+                  <a:srgbClr val="003262"/>
+                </a:solidFill>
+                <a:latin typeface="Arial"/>
+              </a:rPr>
+              <a:t>Single continuous task:  </a:t>
+            </a:r>
+            <a:r>
+              <a:rPr sz="1900">
+                <a:solidFill>
+                  <a:srgbClr val="1A1F2B"/>
+                </a:solidFill>
+                <a:latin typeface="Arial"/>
+              </a:rPr>
+              <a:t>no second human reviewer; transcript and cumulative budget travel across the switch — the sidebar shows the price of the second opinion.</a:t>
+            </a:r>
+          </a:p>
+        </p:txBody>
+      </p:sp>
+      <p:sp>
+        <p:nvSpPr>
+          <p:cNvPr id="7" name="Rectangle 6"/>
+          <p:cNvSpPr/>
+          <p:nvPr/>
+        </p:nvSpPr>
+        <p:spPr>
+          <a:xfrm>
+            <a:off x="7178040" y="2743200"/>
+            <a:ext cx="4160520" cy="3200400"/>
+          </a:xfrm>
+          <a:prstGeom prst="rect">
+            <a:avLst/>
+          </a:prstGeom>
+          <a:solidFill>
+            <a:srgbClr val="003262"/>
+          </a:solidFill>
+          <a:ln>
+            <a:noFill/>
+          </a:ln>
+          <a:effectLst/>
+        </p:spPr>
+        <p:style>
+          <a:lnRef idx="1">
+            <a:schemeClr val="accent1"/>
+          </a:lnRef>
+          <a:fillRef idx="3">
+            <a:schemeClr val="accent1"/>
+          </a:fillRef>
+          <a:effectRef idx="2">
+            <a:schemeClr val="accent1"/>
+          </a:effectRef>
+          <a:fontRef idx="minor">
+            <a:schemeClr val="lt1"/>
+          </a:fontRef>
+        </p:style>
+        <p:txBody>
+          <a:bodyPr rtlCol="0" anchor="ctr"/>
+          <a:lstStyle/>
+          <a:p>
+            <a:pPr algn="ctr"/>
+            <a:endParaRPr/>
+          </a:p>
+        </p:txBody>
+      </p:sp>
+      <p:sp>
+        <p:nvSpPr>
+          <p:cNvPr id="8" name="Rectangle 7"/>
+          <p:cNvSpPr/>
+          <p:nvPr/>
+        </p:nvSpPr>
+        <p:spPr>
+          <a:xfrm>
+            <a:off x="7178040" y="2743200"/>
+            <a:ext cx="4160520" cy="109728"/>
+          </a:xfrm>
+          <a:prstGeom prst="rect">
+            <a:avLst/>
+          </a:prstGeom>
+          <a:solidFill>
+            <a:srgbClr val="FDB515"/>
+          </a:solidFill>
+          <a:ln>
+            <a:noFill/>
+          </a:ln>
+          <a:effectLst/>
+        </p:spPr>
+        <p:style>
+          <a:lnRef idx="1">
+            <a:schemeClr val="accent1"/>
+          </a:lnRef>
+          <a:fillRef idx="3">
+            <a:schemeClr val="accent1"/>
+          </a:fillRef>
+          <a:effectRef idx="2">
+            <a:schemeClr val="accent1"/>
+          </a:effectRef>
+          <a:fontRef idx="minor">
+            <a:schemeClr val="lt1"/>
+          </a:fontRef>
+        </p:style>
+        <p:txBody>
+          <a:bodyPr rtlCol="0" anchor="ctr"/>
+          <a:lstStyle/>
+          <a:p>
+            <a:pPr algn="ctr"/>
+            <a:endParaRPr/>
+          </a:p>
+        </p:txBody>
+      </p:sp>
+      <p:sp>
+        <p:nvSpPr>
+          <p:cNvPr id="9" name="TextBox 8"/>
+          <p:cNvSpPr txBox="1"/>
+          <p:nvPr/>
+        </p:nvSpPr>
+        <p:spPr>
+          <a:xfrm>
+            <a:off x="7498080" y="3063240"/>
+            <a:ext cx="3520440" cy="2651760"/>
+          </a:xfrm>
+          <a:prstGeom prst="rect">
+            <a:avLst/>
+          </a:prstGeom>
+          <a:noFill/>
+        </p:spPr>
+        <p:txBody>
+          <a:bodyPr wrap="square" lIns="0" tIns="0" rIns="0" bIns="0" anchor="ctr">
+            <a:spAutoFit/>
+          </a:bodyPr>
+          <a:lstStyle/>
+          <a:p>
+            <a:pPr algn="l">
+              <a:lnSpc>
+                <a:spcPct val="100000"/>
+              </a:lnSpc>
+              <a:spcBef>
+                <a:spcPts val="0"/>
+              </a:spcBef>
+              <a:spcAft>
+                <a:spcPts val="1200"/>
+              </a:spcAft>
+            </a:pPr>
+            <a:r>
+              <a:rPr sz="1300" b="1" i="0">
+                <a:solidFill>
+                  <a:srgbClr val="FDB515"/>
+                </a:solidFill>
+                <a:latin typeface="Arial"/>
+              </a:rPr>
+              <a:t>From the log</a:t>
+            </a:r>
+          </a:p>
+          <a:p>
+            <a:pPr algn="l">
+              <a:lnSpc>
+                <a:spcPct val="112000"/>
+              </a:lnSpc>
+              <a:spcBef>
+                <a:spcPts val="0"/>
+              </a:spcBef>
+              <a:spcAft>
+                <a:spcPts val="800"/>
+              </a:spcAft>
+            </a:pPr>
+            <a:r>
+              <a:rPr sz="1900" b="0" i="1">
+                <a:solidFill>
+                  <a:srgbClr val="FFFFFF"/>
+                </a:solidFill>
+                <a:latin typeface="Arial"/>
+              </a:rPr>
+              <a:t>“Use claude-opus-4-7 for coding, bug fixing, and test creation. Use gpt-5.5 (not codex) for thorough review and debugging of the work done by the other model.”</a:t>
+            </a:r>
+          </a:p>
+        </p:txBody>
+      </p:sp>
+    </p:spTree>
+  </p:cSld>
+  <p:clrMapOvr>
+    <a:masterClrMapping/>
+  </p:clrMapOvr>
+</p:sld>
+</file>
+
 <file path=ppt/slides/slide3.xml><?xml version="1.0" encoding="utf-8"?>
 <p:sld xmlns:a="http://schemas.openxmlformats.org/drawingml/2006/main" xmlns:r="http://schemas.openxmlformats.org/officeDocument/2006/relationships" xmlns:p="http://schemas.openxmlformats.org/presentationml/2006/main">
   <p:cSld>
@@ -22059,7 +23113,7 @@
                 </a:solidFill>
                 <a:latin typeface="Arial"/>
               </a:rPr>
-              <a:t>Seven recurring usage patterns</a:t>
+              <a:t>Nine recurring usage patterns</a:t>
             </a:r>
           </a:p>
         </p:txBody>
@@ -22072,7 +23126,7 @@
         </p:nvSpPr>
         <p:spPr>
           <a:xfrm>
-            <a:off x="822960" y="2011680"/>
+            <a:off x="822960" y="1920240"/>
             <a:ext cx="5166360" cy="868680"/>
           </a:xfrm>
           <a:prstGeom prst="rect">
@@ -22119,7 +23173,7 @@
         </p:nvSpPr>
         <p:spPr>
           <a:xfrm>
-            <a:off x="822960" y="2011680"/>
+            <a:off x="822960" y="1920240"/>
             <a:ext cx="640080" cy="868680"/>
           </a:xfrm>
           <a:prstGeom prst="rect">
@@ -22164,7 +23218,7 @@
         </p:nvSpPr>
         <p:spPr>
           <a:xfrm>
-            <a:off x="822960" y="2011680"/>
+            <a:off x="822960" y="1920240"/>
             <a:ext cx="640080" cy="868680"/>
           </a:xfrm>
           <a:prstGeom prst="rect">
@@ -22209,7 +23263,7 @@
         </p:nvSpPr>
         <p:spPr>
           <a:xfrm>
-            <a:off x="1691640" y="2011680"/>
+            <a:off x="1691640" y="1920240"/>
             <a:ext cx="4069080" cy="868680"/>
           </a:xfrm>
           <a:prstGeom prst="rect">
@@ -22254,7 +23308,7 @@
         </p:nvSpPr>
         <p:spPr>
           <a:xfrm>
-            <a:off x="6172200" y="2011680"/>
+            <a:off x="6172200" y="1920240"/>
             <a:ext cx="5166360" cy="868680"/>
           </a:xfrm>
           <a:prstGeom prst="rect">
@@ -22301,7 +23355,7 @@
         </p:nvSpPr>
         <p:spPr>
           <a:xfrm>
-            <a:off x="6172200" y="2011680"/>
+            <a:off x="6172200" y="1920240"/>
             <a:ext cx="640080" cy="868680"/>
           </a:xfrm>
           <a:prstGeom prst="rect">
@@ -22346,7 +23400,7 @@
         </p:nvSpPr>
         <p:spPr>
           <a:xfrm>
-            <a:off x="6172200" y="2011680"/>
+            <a:off x="6172200" y="1920240"/>
             <a:ext cx="640080" cy="868680"/>
           </a:xfrm>
           <a:prstGeom prst="rect">
@@ -22391,7 +23445,7 @@
         </p:nvSpPr>
         <p:spPr>
           <a:xfrm>
-            <a:off x="7040880" y="2011680"/>
+            <a:off x="7040880" y="1920240"/>
             <a:ext cx="4069080" cy="868680"/>
           </a:xfrm>
           <a:prstGeom prst="rect">
@@ -22436,7 +23490,7 @@
         </p:nvSpPr>
         <p:spPr>
           <a:xfrm>
-            <a:off x="822960" y="3063240"/>
+            <a:off x="822960" y="2826005"/>
             <a:ext cx="5166360" cy="868680"/>
           </a:xfrm>
           <a:prstGeom prst="rect">
@@ -22483,7 +23537,7 @@
         </p:nvSpPr>
         <p:spPr>
           <a:xfrm>
-            <a:off x="822960" y="3063240"/>
+            <a:off x="822960" y="2826005"/>
             <a:ext cx="640080" cy="868680"/>
           </a:xfrm>
           <a:prstGeom prst="rect">
@@ -22528,7 +23582,7 @@
         </p:nvSpPr>
         <p:spPr>
           <a:xfrm>
-            <a:off x="822960" y="3063240"/>
+            <a:off x="822960" y="2826005"/>
             <a:ext cx="640080" cy="868680"/>
           </a:xfrm>
           <a:prstGeom prst="rect">
@@ -22573,7 +23627,7 @@
         </p:nvSpPr>
         <p:spPr>
           <a:xfrm>
-            <a:off x="1691640" y="3063240"/>
+            <a:off x="1691640" y="2826005"/>
             <a:ext cx="4069080" cy="868680"/>
           </a:xfrm>
           <a:prstGeom prst="rect">
@@ -22618,7 +23672,7 @@
         </p:nvSpPr>
         <p:spPr>
           <a:xfrm>
-            <a:off x="6172200" y="3063240"/>
+            <a:off x="6172200" y="2826005"/>
             <a:ext cx="5166360" cy="868680"/>
           </a:xfrm>
           <a:prstGeom prst="rect">
@@ -22665,7 +23719,7 @@
         </p:nvSpPr>
         <p:spPr>
           <a:xfrm>
-            <a:off x="6172200" y="3063240"/>
+            <a:off x="6172200" y="2826005"/>
             <a:ext cx="640080" cy="868680"/>
           </a:xfrm>
           <a:prstGeom prst="rect">
@@ -22710,7 +23764,7 @@
         </p:nvSpPr>
         <p:spPr>
           <a:xfrm>
-            <a:off x="6172200" y="3063240"/>
+            <a:off x="6172200" y="2826005"/>
             <a:ext cx="640080" cy="868680"/>
           </a:xfrm>
           <a:prstGeom prst="rect">
@@ -22755,7 +23809,7 @@
         </p:nvSpPr>
         <p:spPr>
           <a:xfrm>
-            <a:off x="7040880" y="3063240"/>
+            <a:off x="7040880" y="2826005"/>
             <a:ext cx="4069080" cy="868680"/>
           </a:xfrm>
           <a:prstGeom prst="rect">
@@ -22800,7 +23854,7 @@
         </p:nvSpPr>
         <p:spPr>
           <a:xfrm>
-            <a:off x="822960" y="4114800"/>
+            <a:off x="822960" y="3731770"/>
             <a:ext cx="5166360" cy="868680"/>
           </a:xfrm>
           <a:prstGeom prst="rect">
@@ -22847,7 +23901,7 @@
         </p:nvSpPr>
         <p:spPr>
           <a:xfrm>
-            <a:off x="822960" y="4114800"/>
+            <a:off x="822960" y="3731770"/>
             <a:ext cx="640080" cy="868680"/>
           </a:xfrm>
           <a:prstGeom prst="rect">
@@ -22892,7 +23946,7 @@
         </p:nvSpPr>
         <p:spPr>
           <a:xfrm>
-            <a:off x="822960" y="4114800"/>
+            <a:off x="822960" y="3731770"/>
             <a:ext cx="640080" cy="868680"/>
           </a:xfrm>
           <a:prstGeom prst="rect">
@@ -22937,7 +23991,7 @@
         </p:nvSpPr>
         <p:spPr>
           <a:xfrm>
-            <a:off x="1691640" y="4114800"/>
+            <a:off x="1691640" y="3731770"/>
             <a:ext cx="4069080" cy="868680"/>
           </a:xfrm>
           <a:prstGeom prst="rect">
@@ -22982,7 +24036,7 @@
         </p:nvSpPr>
         <p:spPr>
           <a:xfrm>
-            <a:off x="6172200" y="4114800"/>
+            <a:off x="6172200" y="3731770"/>
             <a:ext cx="5166360" cy="868680"/>
           </a:xfrm>
           <a:prstGeom prst="rect">
@@ -23029,7 +24083,7 @@
         </p:nvSpPr>
         <p:spPr>
           <a:xfrm>
-            <a:off x="6172200" y="4114800"/>
+            <a:off x="6172200" y="3731770"/>
             <a:ext cx="640080" cy="868680"/>
           </a:xfrm>
           <a:prstGeom prst="rect">
@@ -23074,7 +24128,7 @@
         </p:nvSpPr>
         <p:spPr>
           <a:xfrm>
-            <a:off x="6172200" y="4114800"/>
+            <a:off x="6172200" y="3731770"/>
             <a:ext cx="640080" cy="868680"/>
           </a:xfrm>
           <a:prstGeom prst="rect">
@@ -23119,7 +24173,7 @@
         </p:nvSpPr>
         <p:spPr>
           <a:xfrm>
-            <a:off x="7040880" y="4114800"/>
+            <a:off x="7040880" y="3731770"/>
             <a:ext cx="4069080" cy="868680"/>
           </a:xfrm>
           <a:prstGeom prst="rect">
@@ -23164,7 +24218,7 @@
         </p:nvSpPr>
         <p:spPr>
           <a:xfrm>
-            <a:off x="822960" y="5166360"/>
+            <a:off x="822960" y="4637535"/>
             <a:ext cx="5166360" cy="868680"/>
           </a:xfrm>
           <a:prstGeom prst="rect">
@@ -23211,7 +24265,7 @@
         </p:nvSpPr>
         <p:spPr>
           <a:xfrm>
-            <a:off x="822960" y="5166360"/>
+            <a:off x="822960" y="4637535"/>
             <a:ext cx="640080" cy="868680"/>
           </a:xfrm>
           <a:prstGeom prst="rect">
@@ -23256,7 +24310,7 @@
         </p:nvSpPr>
         <p:spPr>
           <a:xfrm>
-            <a:off x="822960" y="5166360"/>
+            <a:off x="822960" y="4637535"/>
             <a:ext cx="640080" cy="868680"/>
           </a:xfrm>
           <a:prstGeom prst="rect">
@@ -23301,7 +24355,7 @@
         </p:nvSpPr>
         <p:spPr>
           <a:xfrm>
-            <a:off x="1691640" y="5166360"/>
+            <a:off x="1691640" y="4637535"/>
             <a:ext cx="4069080" cy="868680"/>
           </a:xfrm>
           <a:prstGeom prst="rect">
@@ -23469,6 +24523,370 @@
                 <a:latin typeface="Arial"/>
               </a:rPr>
               <a:t>07</a:t>
+            </a:r>
+          </a:p>
+        </p:txBody>
+      </p:sp>
+      <p:sp>
+        <p:nvSpPr>
+          <p:cNvPr id="29" name="Rectangle 28"/>
+          <p:cNvSpPr/>
+          <p:nvPr/>
+        </p:nvSpPr>
+        <p:spPr>
+          <a:xfrm>
+            <a:off x="6172200" y="4637535"/>
+            <a:ext cx="5166360" cy="868680"/>
+          </a:xfrm>
+          <a:prstGeom prst="rect">
+            <a:avLst/>
+          </a:prstGeom>
+          <a:solidFill>
+            <a:srgbClr val="FFFFFF"/>
+          </a:solidFill>
+          <a:ln w="12700">
+            <a:solidFill>
+              <a:srgbClr val="E9E5D8"/>
+            </a:solidFill>
+          </a:ln>
+          <a:effectLst/>
+        </p:spPr>
+        <p:style>
+          <a:lnRef idx="1">
+            <a:schemeClr val="accent1"/>
+          </a:lnRef>
+          <a:fillRef idx="3">
+            <a:schemeClr val="accent1"/>
+          </a:fillRef>
+          <a:effectRef idx="2">
+            <a:schemeClr val="accent1"/>
+          </a:effectRef>
+          <a:fontRef idx="minor">
+            <a:schemeClr val="lt1"/>
+          </a:fontRef>
+        </p:style>
+        <p:txBody>
+          <a:bodyPr rtlCol="0" anchor="ctr"/>
+          <a:lstStyle/>
+          <a:p>
+            <a:pPr algn="ctr"/>
+            <a:endParaRPr/>
+          </a:p>
+        </p:txBody>
+      </p:sp>
+      <p:sp>
+        <p:nvSpPr>
+          <p:cNvPr id="30" name="Rectangle 29"/>
+          <p:cNvSpPr/>
+          <p:nvPr/>
+        </p:nvSpPr>
+        <p:spPr>
+          <a:xfrm>
+            <a:off x="6172200" y="4637535"/>
+            <a:ext cx="640080" cy="868680"/>
+          </a:xfrm>
+          <a:prstGeom prst="rect">
+            <a:avLst/>
+          </a:prstGeom>
+          <a:solidFill>
+            <a:srgbClr val="003262"/>
+          </a:solidFill>
+          <a:ln>
+            <a:noFill/>
+          </a:ln>
+          <a:effectLst/>
+        </p:spPr>
+        <p:style>
+          <a:lnRef idx="1">
+            <a:schemeClr val="accent1"/>
+          </a:lnRef>
+          <a:fillRef idx="3">
+            <a:schemeClr val="accent1"/>
+          </a:fillRef>
+          <a:effectRef idx="2">
+            <a:schemeClr val="accent1"/>
+          </a:effectRef>
+          <a:fontRef idx="minor">
+            <a:schemeClr val="lt1"/>
+          </a:fontRef>
+        </p:style>
+        <p:txBody>
+          <a:bodyPr rtlCol="0" anchor="ctr"/>
+          <a:lstStyle/>
+          <a:p>
+            <a:pPr algn="ctr"/>
+            <a:endParaRPr/>
+          </a:p>
+        </p:txBody>
+      </p:sp>
+      <p:sp>
+        <p:nvSpPr>
+          <p:cNvPr id="31" name="TextBox 30"/>
+          <p:cNvSpPr txBox="1"/>
+          <p:nvPr/>
+        </p:nvSpPr>
+        <p:spPr>
+          <a:xfrm>
+            <a:off x="6172200" y="4637535"/>
+            <a:ext cx="640080" cy="868680"/>
+          </a:xfrm>
+          <a:prstGeom prst="rect">
+            <a:avLst/>
+          </a:prstGeom>
+          <a:noFill/>
+        </p:spPr>
+        <p:txBody>
+          <a:bodyPr wrap="square" lIns="0" tIns="0" rIns="0" bIns="0" anchor="ctr">
+            <a:spAutoFit/>
+          </a:bodyPr>
+          <a:lstStyle/>
+          <a:p>
+            <a:pPr algn="ctr">
+              <a:lnSpc>
+                <a:spcPct val="100000"/>
+              </a:lnSpc>
+              <a:spcBef>
+                <a:spcPts val="0"/>
+              </a:spcBef>
+              <a:spcAft>
+                <a:spcPts val="800"/>
+              </a:spcAft>
+            </a:pPr>
+            <a:r>
+              <a:rPr sz="3000" b="1" i="0">
+                <a:solidFill>
+                  <a:srgbClr val="FDB515"/>
+                </a:solidFill>
+                <a:latin typeface="Arial"/>
+              </a:rPr>
+              <a:t>8</a:t>
+            </a:r>
+          </a:p>
+        </p:txBody>
+      </p:sp>
+      <p:sp>
+        <p:nvSpPr>
+          <p:cNvPr id="32" name="TextBox 31"/>
+          <p:cNvSpPr txBox="1"/>
+          <p:nvPr/>
+        </p:nvSpPr>
+        <p:spPr>
+          <a:xfrm>
+            <a:off x="7040880" y="4637535"/>
+            <a:ext cx="4069080" cy="868680"/>
+          </a:xfrm>
+          <a:prstGeom prst="rect">
+            <a:avLst/>
+          </a:prstGeom>
+          <a:noFill/>
+        </p:spPr>
+        <p:txBody>
+          <a:bodyPr wrap="square" lIns="0" tIns="0" rIns="0" bIns="0" anchor="ctr">
+            <a:spAutoFit/>
+          </a:bodyPr>
+          <a:lstStyle/>
+          <a:p>
+            <a:pPr algn="l">
+              <a:lnSpc>
+                <a:spcPct val="100000"/>
+              </a:lnSpc>
+              <a:spcBef>
+                <a:spcPts val="0"/>
+              </a:spcBef>
+              <a:spcAft>
+                <a:spcPts val="800"/>
+              </a:spcAft>
+            </a:pPr>
+            <a:r>
+              <a:rPr sz="2000" b="1" i="0">
+                <a:solidFill>
+                  <a:srgbClr val="003262"/>
+                </a:solidFill>
+                <a:latin typeface="Arial"/>
+              </a:rPr>
+              <a:t>Invariant specification and repair</a:t>
+            </a:r>
+          </a:p>
+        </p:txBody>
+      </p:sp>
+      <p:sp>
+        <p:nvSpPr>
+          <p:cNvPr id="29" name="Rectangle 28"/>
+          <p:cNvSpPr/>
+          <p:nvPr/>
+        </p:nvSpPr>
+        <p:spPr>
+          <a:xfrm>
+            <a:off x="822960" y="5543300"/>
+            <a:ext cx="5166360" cy="868680"/>
+          </a:xfrm>
+          <a:prstGeom prst="rect">
+            <a:avLst/>
+          </a:prstGeom>
+          <a:solidFill>
+            <a:srgbClr val="FFFFFF"/>
+          </a:solidFill>
+          <a:ln w="12700">
+            <a:solidFill>
+              <a:srgbClr val="E9E5D8"/>
+            </a:solidFill>
+          </a:ln>
+          <a:effectLst/>
+        </p:spPr>
+        <p:style>
+          <a:lnRef idx="1">
+            <a:schemeClr val="accent1"/>
+          </a:lnRef>
+          <a:fillRef idx="3">
+            <a:schemeClr val="accent1"/>
+          </a:fillRef>
+          <a:effectRef idx="2">
+            <a:schemeClr val="accent1"/>
+          </a:effectRef>
+          <a:fontRef idx="minor">
+            <a:schemeClr val="lt1"/>
+          </a:fontRef>
+        </p:style>
+        <p:txBody>
+          <a:bodyPr rtlCol="0" anchor="ctr"/>
+          <a:lstStyle/>
+          <a:p>
+            <a:pPr algn="ctr"/>
+            <a:endParaRPr/>
+          </a:p>
+        </p:txBody>
+      </p:sp>
+      <p:sp>
+        <p:nvSpPr>
+          <p:cNvPr id="30" name="Rectangle 29"/>
+          <p:cNvSpPr/>
+          <p:nvPr/>
+        </p:nvSpPr>
+        <p:spPr>
+          <a:xfrm>
+            <a:off x="822960" y="5543300"/>
+            <a:ext cx="640080" cy="868680"/>
+          </a:xfrm>
+          <a:prstGeom prst="rect">
+            <a:avLst/>
+          </a:prstGeom>
+          <a:solidFill>
+            <a:srgbClr val="003262"/>
+          </a:solidFill>
+          <a:ln>
+            <a:noFill/>
+          </a:ln>
+          <a:effectLst/>
+        </p:spPr>
+        <p:style>
+          <a:lnRef idx="1">
+            <a:schemeClr val="accent1"/>
+          </a:lnRef>
+          <a:fillRef idx="3">
+            <a:schemeClr val="accent1"/>
+          </a:fillRef>
+          <a:effectRef idx="2">
+            <a:schemeClr val="accent1"/>
+          </a:effectRef>
+          <a:fontRef idx="minor">
+            <a:schemeClr val="lt1"/>
+          </a:fontRef>
+        </p:style>
+        <p:txBody>
+          <a:bodyPr rtlCol="0" anchor="ctr"/>
+          <a:lstStyle/>
+          <a:p>
+            <a:pPr algn="ctr"/>
+            <a:endParaRPr/>
+          </a:p>
+        </p:txBody>
+      </p:sp>
+      <p:sp>
+        <p:nvSpPr>
+          <p:cNvPr id="31" name="TextBox 30"/>
+          <p:cNvSpPr txBox="1"/>
+          <p:nvPr/>
+        </p:nvSpPr>
+        <p:spPr>
+          <a:xfrm>
+            <a:off x="822960" y="5543300"/>
+            <a:ext cx="640080" cy="868680"/>
+          </a:xfrm>
+          <a:prstGeom prst="rect">
+            <a:avLst/>
+          </a:prstGeom>
+          <a:noFill/>
+        </p:spPr>
+        <p:txBody>
+          <a:bodyPr wrap="square" lIns="0" tIns="0" rIns="0" bIns="0" anchor="ctr">
+            <a:spAutoFit/>
+          </a:bodyPr>
+          <a:lstStyle/>
+          <a:p>
+            <a:pPr algn="ctr">
+              <a:lnSpc>
+                <a:spcPct val="100000"/>
+              </a:lnSpc>
+              <a:spcBef>
+                <a:spcPts val="0"/>
+              </a:spcBef>
+              <a:spcAft>
+                <a:spcPts val="800"/>
+              </a:spcAft>
+            </a:pPr>
+            <a:r>
+              <a:rPr sz="3000" b="1" i="0">
+                <a:solidFill>
+                  <a:srgbClr val="FDB515"/>
+                </a:solidFill>
+                <a:latin typeface="Arial"/>
+              </a:rPr>
+              <a:t>9</a:t>
+            </a:r>
+          </a:p>
+        </p:txBody>
+      </p:sp>
+      <p:sp>
+        <p:nvSpPr>
+          <p:cNvPr id="32" name="TextBox 31"/>
+          <p:cNvSpPr txBox="1"/>
+          <p:nvPr/>
+        </p:nvSpPr>
+        <p:spPr>
+          <a:xfrm>
+            <a:off x="1691640" y="5543300"/>
+            <a:ext cx="4069080" cy="868680"/>
+          </a:xfrm>
+          <a:prstGeom prst="rect">
+            <a:avLst/>
+          </a:prstGeom>
+          <a:noFill/>
+        </p:spPr>
+        <p:txBody>
+          <a:bodyPr wrap="square" lIns="0" tIns="0" rIns="0" bIns="0" anchor="ctr">
+            <a:spAutoFit/>
+          </a:bodyPr>
+          <a:lstStyle/>
+          <a:p>
+            <a:pPr algn="l">
+              <a:lnSpc>
+                <a:spcPct val="100000"/>
+              </a:lnSpc>
+              <a:spcBef>
+                <a:spcPts val="0"/>
+              </a:spcBef>
+              <a:spcAft>
+                <a:spcPts val="800"/>
+              </a:spcAft>
+            </a:pPr>
+            <a:r>
+              <a:rPr sz="2000" b="1" i="0">
+                <a:solidFill>
+                  <a:srgbClr val="003262"/>
+                </a:solidFill>
+                <a:latin typeface="Arial"/>
+              </a:rPr>
+              <a:t>Cross-model iterative review</a:t>
             </a:r>
           </a:p>
         </p:txBody>

</xml_diff>

<commit_message>
docs: update slides and rebuild paper
- Updated presentation slides to reflect paper revisions
- Rebuilt paper PDF from source

User prompt:
can you update the slides at ./papers/sekisssorcar/se_kiss_sorcar_slides.pptx based on the updated paper at ./papers/sekisssorcar/se_kiss_sorcar.tex ?  Build the paper.
</commit_message>
<xml_diff>
--- a/papers/sekisssorcar/se_kiss_sorcar_slides.pptx
+++ b/papers/sekisssorcar/se_kiss_sorcar_slides.pptx
@@ -15,6 +15,7 @@
     <p:sldId id="263" r:id="rId9"/>
     <p:sldId id="264" r:id="rId10"/>
     <p:sldId id="265" r:id="rId11"/>
+    <p:sldId id="318" r:id="rId35"/>
     <p:sldId id="267" r:id="rId12"/>
     <p:sldId id="268" r:id="rId13"/>
     <p:sldId id="269" r:id="rId14"/>
@@ -18931,6 +18932,390 @@
                 <a:latin typeface="Arial"/>
               </a:rPr>
               <a:t>03</a:t>
+            </a:r>
+          </a:p>
+        </p:txBody>
+      </p:sp>
+    </p:spTree>
+  </p:cSld>
+  <p:clrMapOvr>
+    <a:masterClrMapping/>
+  </p:clrMapOvr>
+</p:sld>
+</file>
+
+<file path=ppt/slides/slide30.xml><?xml version="1.0" encoding="utf-8"?>
+<p:sld xmlns:a="http://schemas.openxmlformats.org/drawingml/2006/main" xmlns:r="http://schemas.openxmlformats.org/officeDocument/2006/relationships" xmlns:p="http://schemas.openxmlformats.org/presentationml/2006/main">
+  <p:cSld>
+    <p:bg>
+      <p:bgPr>
+        <a:solidFill>
+          <a:srgbClr val="F7F5EF"/>
+        </a:solidFill>
+        <a:effectLst/>
+      </p:bgPr>
+    </p:bg>
+    <p:spTree>
+      <p:nvGrpSpPr>
+        <p:cNvPr id="1" name=""/>
+        <p:cNvGrpSpPr/>
+        <p:nvPr/>
+      </p:nvGrpSpPr>
+      <p:grpSpPr>
+        <a:xfrm>
+          <a:off x="0" y="0"/>
+          <a:ext cx="0" cy="0"/>
+          <a:chOff x="0" y="0"/>
+          <a:chExt cx="0" cy="0"/>
+        </a:xfrm>
+      </p:grpSpPr>
+      <p:sp>
+        <p:nvSpPr>
+          <p:cNvPr id="2" name="Rectangle 1"/>
+          <p:cNvSpPr/>
+          <p:nvPr/>
+        </p:nvSpPr>
+        <p:spPr>
+          <a:xfrm>
+            <a:off x="457200" y="914400"/>
+            <a:ext cx="146304" cy="502920"/>
+          </a:xfrm>
+          <a:prstGeom prst="rect">
+            <a:avLst/>
+          </a:prstGeom>
+          <a:solidFill>
+            <a:srgbClr val="FDB515"/>
+          </a:solidFill>
+          <a:ln>
+            <a:noFill/>
+          </a:ln>
+          <a:effectLst/>
+        </p:spPr>
+        <p:style>
+          <a:lnRef idx="1">
+            <a:schemeClr val="accent1"/>
+          </a:lnRef>
+          <a:fillRef idx="3">
+            <a:schemeClr val="accent1"/>
+          </a:fillRef>
+          <a:effectRef idx="2">
+            <a:schemeClr val="accent1"/>
+          </a:effectRef>
+          <a:fontRef idx="minor">
+            <a:schemeClr val="lt1"/>
+          </a:fontRef>
+        </p:style>
+        <p:txBody>
+          <a:bodyPr rtlCol="0" anchor="ctr"/>
+          <a:lstStyle/>
+          <a:p>
+            <a:pPr algn="ctr"/>
+            <a:endParaRPr/>
+          </a:p>
+        </p:txBody>
+      </p:sp>
+      <p:sp>
+        <p:nvSpPr>
+          <p:cNvPr id="3" name="TextBox 2"/>
+          <p:cNvSpPr txBox="1"/>
+          <p:nvPr/>
+        </p:nvSpPr>
+        <p:spPr>
+          <a:xfrm>
+            <a:off x="822960" y="502920"/>
+            <a:ext cx="10515600" cy="365760"/>
+          </a:xfrm>
+          <a:prstGeom prst="rect">
+            <a:avLst/>
+          </a:prstGeom>
+          <a:noFill/>
+        </p:spPr>
+        <p:txBody>
+          <a:bodyPr wrap="square" lIns="0" tIns="0" rIns="0" bIns="0" anchor="t">
+            <a:spAutoFit/>
+          </a:bodyPr>
+          <a:lstStyle/>
+          <a:p>
+            <a:pPr algn="l">
+              <a:lnSpc>
+                <a:spcPct val="100000"/>
+              </a:lnSpc>
+              <a:spcBef>
+                <a:spcPts val="0"/>
+              </a:spcBef>
+              <a:spcAft>
+                <a:spcPts val="800"/>
+              </a:spcAft>
+            </a:pPr>
+            <a:r>
+              <a:rPr sz="1300" b="1" i="0">
+                <a:solidFill>
+                  <a:srgbClr val="C88A00"/>
+                </a:solidFill>
+                <a:latin typeface="Arial"/>
+              </a:rPr>
+              <a:t>P  A  T  T  E  R  N     4</a:t>
+            </a:r>
+          </a:p>
+        </p:txBody>
+      </p:sp>
+      <p:sp>
+        <p:nvSpPr>
+          <p:cNvPr id="4" name="TextBox 3"/>
+          <p:cNvSpPr txBox="1"/>
+          <p:nvPr/>
+        </p:nvSpPr>
+        <p:spPr>
+          <a:xfrm>
+            <a:off x="822960" y="868680"/>
+            <a:ext cx="10515600" cy="1280160"/>
+          </a:xfrm>
+          <a:prstGeom prst="rect">
+            <a:avLst/>
+          </a:prstGeom>
+          <a:noFill/>
+        </p:spPr>
+        <p:txBody>
+          <a:bodyPr wrap="square" lIns="0" tIns="0" rIns="0" bIns="0" anchor="t">
+            <a:spAutoFit/>
+          </a:bodyPr>
+          <a:lstStyle/>
+          <a:p>
+            <a:pPr algn="l">
+              <a:lnSpc>
+                <a:spcPct val="100000"/>
+              </a:lnSpc>
+              <a:spcBef>
+                <a:spcPts val="0"/>
+              </a:spcBef>
+              <a:spcAft>
+                <a:spcPts val="800"/>
+              </a:spcAft>
+            </a:pPr>
+            <a:r>
+              <a:rPr sz="3400" b="1" i="0">
+                <a:solidFill>
+                  <a:srgbClr val="003262"/>
+                </a:solidFill>
+                <a:latin typeface="Arial"/>
+              </a:rPr>
+              <a:t>Paper–code co-evolution</a:t>
+            </a:r>
+          </a:p>
+        </p:txBody>
+      </p:sp>
+      <p:sp>
+        <p:nvSpPr>
+          <p:cNvPr id="5" name="TextBox 4"/>
+          <p:cNvSpPr txBox="1"/>
+          <p:nvPr/>
+        </p:nvSpPr>
+        <p:spPr>
+          <a:xfrm>
+            <a:off x="822960" y="1783080"/>
+            <a:ext cx="10607040" cy="822960"/>
+          </a:xfrm>
+          <a:prstGeom prst="rect">
+            <a:avLst/>
+          </a:prstGeom>
+          <a:noFill/>
+        </p:spPr>
+        <p:txBody>
+          <a:bodyPr wrap="square" lIns="0" tIns="0" rIns="0" bIns="0" anchor="t">
+            <a:spAutoFit/>
+          </a:bodyPr>
+          <a:lstStyle/>
+          <a:p>
+            <a:pPr algn="l">
+              <a:lnSpc>
+                <a:spcPct val="112000"/>
+              </a:lnSpc>
+              <a:spcBef>
+                <a:spcPts val="0"/>
+              </a:spcBef>
+              <a:spcAft>
+                <a:spcPts val="800"/>
+              </a:spcAft>
+            </a:pPr>
+            <a:r>
+              <a:rPr sz="2100" b="0" i="0">
+                <a:solidFill>
+                  <a:srgbClr val="4A5260"/>
+                </a:solidFill>
+                <a:latin typeface="Arial"/>
+              </a:rPr>
+              <a:t>The system prompt and the paper describing it evolved together — a self-hosted documentation loop.</a:t>
+            </a:r>
+          </a:p>
+        </p:txBody>
+      </p:sp>
+      <p:sp>
+        <p:nvSpPr>
+          <p:cNvPr id="6" name="TextBox 5"/>
+          <p:cNvSpPr txBox="1"/>
+          <p:nvPr/>
+        </p:nvSpPr>
+        <p:spPr>
+          <a:xfrm>
+            <a:off x="822960" y="2743200"/>
+            <a:ext cx="10607040" cy="3383280"/>
+          </a:xfrm>
+          <a:prstGeom prst="rect">
+            <a:avLst/>
+          </a:prstGeom>
+          <a:noFill/>
+        </p:spPr>
+        <p:txBody>
+          <a:bodyPr wrap="square" lIns="0" tIns="0" rIns="0" bIns="0" anchor="t">
+            <a:spAutoFit/>
+          </a:bodyPr>
+          <a:lstStyle/>
+          <a:p>
+            <a:pPr algn="l">
+              <a:lnSpc>
+                <a:spcPct val="106000"/>
+              </a:lnSpc>
+              <a:spcAft>
+                <a:spcPts val="1800"/>
+              </a:spcAft>
+            </a:pPr>
+            <a:r>
+              <a:rPr sz="2100" b="1">
+                <a:solidFill>
+                  <a:srgbClr val="FDB515"/>
+                </a:solidFill>
+                <a:latin typeface="Arial"/>
+              </a:rPr>
+              <a:t>—  </a:t>
+            </a:r>
+            <a:r>
+              <a:rPr sz="2100" b="1">
+                <a:solidFill>
+                  <a:srgbClr val="003262"/>
+                </a:solidFill>
+                <a:latin typeface="Arial"/>
+              </a:rPr>
+              <a:t>Code-to-paper:  </a:t>
+            </a:r>
+            <a:r>
+              <a:rPr sz="2100">
+                <a:solidFill>
+                  <a:srgbClr val="1A1F2B"/>
+                </a:solidFill>
+                <a:latin typeface="Arial"/>
+              </a:rPr>
+              <a:t>“SYSTEM.md has changed — update and build the paper” (Tasks 84, 167, 233, 261, 274, 312, 665, 693, 766…).</a:t>
+            </a:r>
+          </a:p>
+          <a:p>
+            <a:pPr algn="l">
+              <a:lnSpc>
+                <a:spcPct val="106000"/>
+              </a:lnSpc>
+              <a:spcAft>
+                <a:spcPts val="1800"/>
+              </a:spcAft>
+            </a:pPr>
+            <a:r>
+              <a:rPr sz="2100" b="1">
+                <a:solidFill>
+                  <a:srgbClr val="FDB515"/>
+                </a:solidFill>
+                <a:latin typeface="Arial"/>
+              </a:rPr>
+              <a:t>—  </a:t>
+            </a:r>
+            <a:r>
+              <a:rPr sz="2100" b="1">
+                <a:solidFill>
+                  <a:srgbClr val="003262"/>
+                </a:solidFill>
+                <a:latin typeface="Arial"/>
+              </a:rPr>
+              <a:t>Consistency audits:  </a:t>
+            </a:r>
+            <a:r>
+              <a:rPr sz="2100">
+                <a:solidFill>
+                  <a:srgbClr val="1A1F2B"/>
+                </a:solidFill>
+                <a:latin typeface="Arial"/>
+              </a:rPr>
+              <a:t>“check the paper against itself and the latest code” closes the loop — divergence is mechanically detectable.</a:t>
+            </a:r>
+          </a:p>
+          <a:p>
+            <a:pPr algn="l">
+              <a:lnSpc>
+                <a:spcPct val="106000"/>
+              </a:lnSpc>
+              <a:spcAft>
+                <a:spcPts val="1800"/>
+              </a:spcAft>
+            </a:pPr>
+            <a:r>
+              <a:rPr sz="2100" b="1">
+                <a:solidFill>
+                  <a:srgbClr val="FDB515"/>
+                </a:solidFill>
+                <a:latin typeface="Arial"/>
+              </a:rPr>
+              <a:t>—  </a:t>
+            </a:r>
+            <a:r>
+              <a:rPr sz="2100" b="1">
+                <a:solidFill>
+                  <a:srgbClr val="003262"/>
+                </a:solidFill>
+                <a:latin typeface="Arial"/>
+              </a:rPr>
+              <a:t>Paper-to-code:  </a:t>
+            </a:r>
+            <a:r>
+              <a:rPr sz="2100">
+                <a:solidFill>
+                  <a:srgbClr val="1A1F2B"/>
+                </a:solidFill>
+                <a:latin typeface="Arial"/>
+              </a:rPr>
+              <a:t>Task 700 used the paper as source of truth — typo fixes in the paper were propagated back into SYSTEM.md.</a:t>
+            </a:r>
+          </a:p>
+          <a:p>
+            <a:pPr algn="l">
+              <a:lnSpc>
+                <a:spcPct val="106000"/>
+              </a:lnSpc>
+              <a:spcAft>
+                <a:spcPts val="1800"/>
+              </a:spcAft>
+            </a:pPr>
+            <a:r>
+              <a:rPr sz="2100" b="1">
+                <a:solidFill>
+                  <a:srgbClr val="FDB515"/>
+                </a:solidFill>
+                <a:latin typeface="Arial"/>
+              </a:rPr>
+              <a:t>—  </a:t>
+            </a:r>
+            <a:r>
+              <a:rPr sz="2100" b="1">
+                <a:solidFill>
+                  <a:srgbClr val="003262"/>
+                </a:solidFill>
+                <a:latin typeface="Arial"/>
+              </a:rPr>
+              <a:t>High volume:  </a:t>
+            </a:r>
+            <a:r>
+              <a:rPr sz="2100">
+                <a:solidFill>
+                  <a:srgbClr val="1A1F2B"/>
+                </a:solidFill>
+                <a:latin typeface="Arial"/>
+              </a:rPr>
+              <a:t>“build the paper” appears in 73 tasks — one of the highest-volume non-coding activities in the log.</a:t>
             </a:r>
           </a:p>
         </p:txBody>

</xml_diff>

<commit_message>
fix: resolve slide formatting and overflow issues
- Adjust slide layouts to prevent content overflow
- Add reference screenshot

User prompt:
the slides are not properly formatted.  They are overflowing.  Fix.
</commit_message>
<xml_diff>
--- a/papers/sekisssorcar/se_kiss_sorcar_slides.pptx
+++ b/papers/sekisssorcar/se_kiss_sorcar_slides.pptx
@@ -5078,7 +5078,7 @@
           <a:lstStyle/>
           <a:p>
             <a:r>
-              <a:rPr sz="1300" b="1" i="0">
+              <a:rPr sz="1100" b="1" i="0">
                 <a:solidFill>
                   <a:srgbClr val="C88A00"/>
                 </a:solidFill>
@@ -5296,7 +5296,7 @@
               </a:lnSpc>
             </a:pPr>
             <a:r>
-              <a:rPr sz="1450" b="0" i="1">
+              <a:rPr sz="1100" b="0" i="1">
                 <a:solidFill>
                   <a:srgbClr val="FFFFFF"/>
                 </a:solidFill>
@@ -5441,7 +5441,7 @@
               </a:lnSpc>
             </a:pPr>
             <a:r>
-              <a:rPr sz="1450" b="0" i="1">
+              <a:rPr sz="1100" b="0" i="1">
                 <a:solidFill>
                   <a:srgbClr val="FFFFFF"/>
                 </a:solidFill>
@@ -5586,7 +5586,7 @@
               </a:lnSpc>
             </a:pPr>
             <a:r>
-              <a:rPr sz="1450" b="0" i="1">
+              <a:rPr sz="1100" b="0" i="1">
                 <a:solidFill>
                   <a:srgbClr val="FFFFFF"/>
                 </a:solidFill>
@@ -5731,7 +5731,7 @@
               </a:lnSpc>
             </a:pPr>
             <a:r>
-              <a:rPr sz="1450" b="0" i="1">
+              <a:rPr sz="1100" b="0" i="1">
                 <a:solidFill>
                   <a:srgbClr val="FFFFFF"/>
                 </a:solidFill>
@@ -5876,7 +5876,7 @@
               </a:lnSpc>
             </a:pPr>
             <a:r>
-              <a:rPr sz="1450" b="0" i="1">
+              <a:rPr sz="1100" b="0" i="1">
                 <a:solidFill>
                   <a:srgbClr val="FFFFFF"/>
                 </a:solidFill>
@@ -6021,7 +6021,7 @@
               </a:lnSpc>
             </a:pPr>
             <a:r>
-              <a:rPr sz="1450" b="0" i="1">
+              <a:rPr sz="1100" b="0" i="1">
                 <a:solidFill>
                   <a:srgbClr val="FFFFFF"/>
                 </a:solidFill>
@@ -6166,7 +6166,7 @@
               </a:lnSpc>
             </a:pPr>
             <a:r>
-              <a:rPr sz="1450" b="0" i="1">
+              <a:rPr sz="1100" b="0" i="1">
                 <a:solidFill>
                   <a:srgbClr val="FFFFFF"/>
                 </a:solidFill>
@@ -6311,7 +6311,7 @@
               </a:lnSpc>
             </a:pPr>
             <a:r>
-              <a:rPr sz="1450" b="0" i="1">
+              <a:rPr sz="1100" b="0" i="1">
                 <a:solidFill>
                   <a:srgbClr val="FFFFFF"/>
                 </a:solidFill>
@@ -6537,7 +6537,7 @@
           <a:lstStyle/>
           <a:p>
             <a:r>
-              <a:rPr sz="1300" b="1" i="0">
+              <a:rPr sz="1100" b="1" i="0">
                 <a:solidFill>
                   <a:srgbClr val="C88A00"/>
                 </a:solidFill>
@@ -6755,7 +6755,7 @@
               </a:lnSpc>
             </a:pPr>
             <a:r>
-              <a:rPr sz="1450" b="0" i="1">
+              <a:rPr sz="1100" b="0" i="1">
                 <a:solidFill>
                   <a:srgbClr val="FFFFFF"/>
                 </a:solidFill>
@@ -6900,7 +6900,7 @@
               </a:lnSpc>
             </a:pPr>
             <a:r>
-              <a:rPr sz="1450" b="0" i="1">
+              <a:rPr sz="1100" b="0" i="1">
                 <a:solidFill>
                   <a:srgbClr val="FFFFFF"/>
                 </a:solidFill>
@@ -7045,7 +7045,7 @@
               </a:lnSpc>
             </a:pPr>
             <a:r>
-              <a:rPr sz="1450" b="0" i="1">
+              <a:rPr sz="1100" b="0" i="1">
                 <a:solidFill>
                   <a:srgbClr val="FFFFFF"/>
                 </a:solidFill>
@@ -7190,7 +7190,7 @@
               </a:lnSpc>
             </a:pPr>
             <a:r>
-              <a:rPr sz="1450" b="0" i="1">
+              <a:rPr sz="1100" b="0" i="1">
                 <a:solidFill>
                   <a:srgbClr val="FFFFFF"/>
                 </a:solidFill>
@@ -7335,7 +7335,7 @@
               </a:lnSpc>
             </a:pPr>
             <a:r>
-              <a:rPr sz="1450" b="0" i="1">
+              <a:rPr sz="1100" b="0" i="1">
                 <a:solidFill>
                   <a:srgbClr val="FFFFFF"/>
                 </a:solidFill>
@@ -7480,7 +7480,7 @@
               </a:lnSpc>
             </a:pPr>
             <a:r>
-              <a:rPr sz="1450" b="0" i="1">
+              <a:rPr sz="1100" b="0" i="1">
                 <a:solidFill>
                   <a:srgbClr val="FFFFFF"/>
                 </a:solidFill>
@@ -7625,7 +7625,7 @@
               </a:lnSpc>
             </a:pPr>
             <a:r>
-              <a:rPr sz="1450" b="0" i="1">
+              <a:rPr sz="1100" b="0" i="1">
                 <a:solidFill>
                   <a:srgbClr val="FFFFFF"/>
                 </a:solidFill>
@@ -7770,7 +7770,7 @@
               </a:lnSpc>
             </a:pPr>
             <a:r>
-              <a:rPr sz="1450" b="0" i="1">
+              <a:rPr sz="1100" b="0" i="1">
                 <a:solidFill>
                   <a:srgbClr val="FFFFFF"/>
                 </a:solidFill>
@@ -15559,7 +15559,7 @@
           <a:lstStyle/>
           <a:p>
             <a:pPr>
-              <a:defRPr sz="1400">
+              <a:defRPr sz="1200">
                 <a:solidFill>
                   <a:srgbClr val="374151"/>
                 </a:solidFill>
@@ -15594,7 +15594,7 @@
           <a:lstStyle/>
           <a:p>
             <a:pPr>
-              <a:defRPr sz="1400">
+              <a:defRPr sz="1200">
                 <a:solidFill>
                   <a:srgbClr val="374151"/>
                 </a:solidFill>
@@ -15629,7 +15629,7 @@
           <a:lstStyle/>
           <a:p>
             <a:pPr>
-              <a:defRPr sz="1400">
+              <a:defRPr sz="1200">
                 <a:solidFill>
                   <a:srgbClr val="374151"/>
                 </a:solidFill>
@@ -15664,7 +15664,7 @@
           <a:lstStyle/>
           <a:p>
             <a:pPr>
-              <a:defRPr sz="1400">
+              <a:defRPr sz="1200">
                 <a:solidFill>
                   <a:srgbClr val="374151"/>
                 </a:solidFill>
@@ -15699,7 +15699,7 @@
           <a:lstStyle/>
           <a:p>
             <a:pPr>
-              <a:defRPr sz="1400">
+              <a:defRPr sz="1200">
                 <a:solidFill>
                   <a:srgbClr val="374151"/>
                 </a:solidFill>
@@ -15788,7 +15788,7 @@
           <a:lstStyle/>
           <a:p>
             <a:pPr>
-              <a:defRPr sz="1400">
+              <a:defRPr sz="1200">
                 <a:solidFill>
                   <a:srgbClr val="374151"/>
                 </a:solidFill>
@@ -15823,7 +15823,7 @@
           <a:lstStyle/>
           <a:p>
             <a:pPr>
-              <a:defRPr sz="1400">
+              <a:defRPr sz="1200">
                 <a:solidFill>
                   <a:srgbClr val="374151"/>
                 </a:solidFill>
@@ -15858,7 +15858,7 @@
           <a:lstStyle/>
           <a:p>
             <a:pPr>
-              <a:defRPr sz="1400">
+              <a:defRPr sz="1200">
                 <a:solidFill>
                   <a:srgbClr val="374151"/>
                 </a:solidFill>
@@ -15893,7 +15893,7 @@
           <a:lstStyle/>
           <a:p>
             <a:pPr>
-              <a:defRPr sz="1400">
+              <a:defRPr sz="1200">
                 <a:solidFill>
                   <a:srgbClr val="374151"/>
                 </a:solidFill>
@@ -15928,7 +15928,7 @@
           <a:lstStyle/>
           <a:p>
             <a:pPr>
-              <a:defRPr sz="1400">
+              <a:defRPr sz="1200">
                 <a:solidFill>
                   <a:srgbClr val="374151"/>
                 </a:solidFill>
@@ -17129,7 +17129,7 @@
               </a:spcAft>
             </a:pPr>
             <a:r>
-              <a:rPr sz="1900" b="1">
+              <a:rPr sz="1500" b="1">
                 <a:solidFill>
                   <a:srgbClr val="FDB515"/>
                 </a:solidFill>
@@ -17138,7 +17138,7 @@
               <a:t>—  </a:t>
             </a:r>
             <a:r>
-              <a:rPr sz="1900" b="1">
+              <a:rPr sz="1500" b="1">
                 <a:solidFill>
                   <a:srgbClr val="003262"/>
                 </a:solidFill>
@@ -17147,7 +17147,7 @@
               <a:t>Five-line template:  </a:t>
             </a:r>
             <a:r>
-              <a:rPr sz="1900">
+              <a:rPr sz="1500">
                 <a:solidFill>
                   <a:srgbClr val="1A1F2B"/>
                 </a:solidFill>
@@ -17166,7 +17166,7 @@
               </a:spcAft>
             </a:pPr>
             <a:r>
-              <a:rPr sz="1900" b="1">
+              <a:rPr sz="1500" b="1">
                 <a:solidFill>
                   <a:srgbClr val="FDB515"/>
                 </a:solidFill>
@@ -17175,7 +17175,7 @@
               <a:t>—  </a:t>
             </a:r>
             <a:r>
-              <a:rPr sz="1900" b="1">
+              <a:rPr sz="1500" b="1">
                 <a:solidFill>
                   <a:srgbClr val="003262"/>
                 </a:solidFill>
@@ -17184,7 +17184,7 @@
               <a:t>Test before fix:  </a:t>
             </a:r>
             <a:r>
-              <a:rPr sz="1900">
+              <a:rPr sz="1500">
                 <a:solidFill>
                   <a:srgbClr val="1A1F2B"/>
                 </a:solidFill>
@@ -17203,7 +17203,7 @@
               </a:spcAft>
             </a:pPr>
             <a:r>
-              <a:rPr sz="1900" b="1">
+              <a:rPr sz="1500" b="1">
                 <a:solidFill>
                   <a:srgbClr val="FDB515"/>
                 </a:solidFill>
@@ -17212,7 +17212,7 @@
               <a:t>—  </a:t>
             </a:r>
             <a:r>
-              <a:rPr sz="1900" b="1">
+              <a:rPr sz="1500" b="1">
                 <a:solidFill>
                   <a:srgbClr val="003262"/>
                 </a:solidFill>
@@ -17221,7 +17221,7 @@
               <a:t>Cross-vendor reviewer:  </a:t>
             </a:r>
             <a:r>
-              <a:rPr sz="1900">
+              <a:rPr sz="1500">
                 <a:solidFill>
                   <a:srgbClr val="1A1F2B"/>
                 </a:solidFill>
@@ -17240,7 +17240,7 @@
               </a:spcAft>
             </a:pPr>
             <a:r>
-              <a:rPr sz="1900" b="1">
+              <a:rPr sz="1500" b="1">
                 <a:solidFill>
                   <a:srgbClr val="FDB515"/>
                 </a:solidFill>
@@ -17249,7 +17249,7 @@
               <a:t>—  </a:t>
             </a:r>
             <a:r>
-              <a:rPr sz="1900" b="1">
+              <a:rPr sz="1500" b="1">
                 <a:solidFill>
                   <a:srgbClr val="003262"/>
                 </a:solidFill>
@@ -17258,7 +17258,7 @@
               <a:t>Generality:  </a:t>
             </a:r>
             <a:r>
-              <a:rPr sz="1900">
+              <a:rPr sz="1500">
                 <a:solidFill>
                   <a:srgbClr val="1A1F2B"/>
                 </a:solidFill>
@@ -17415,7 +17415,7 @@
               </a:spcAft>
             </a:pPr>
             <a:r>
-              <a:rPr sz="1900" b="0" i="1">
+              <a:rPr sz="1500" b="0" i="1">
                 <a:solidFill>
                   <a:srgbClr val="FFFFFF"/>
                 </a:solidFill>
@@ -17655,7 +17655,7 @@
               </a:spcAft>
             </a:pPr>
             <a:r>
-              <a:rPr sz="1900" b="1">
+              <a:rPr sz="1500" b="1">
                 <a:solidFill>
                   <a:srgbClr val="FDB515"/>
                 </a:solidFill>
@@ -17664,7 +17664,7 @@
               <a:t>—  </a:t>
             </a:r>
             <a:r>
-              <a:rPr sz="1900" b="1">
+              <a:rPr sz="1500" b="1">
                 <a:solidFill>
                   <a:srgbClr val="003262"/>
                 </a:solidFill>
@@ -17673,7 +17673,7 @@
               <a:t>set_model tool:  </a:t>
             </a:r>
             <a:r>
-              <a:rPr sz="1900">
+              <a:rPr sz="1500">
                 <a:solidFill>
                   <a:srgbClr val="1A1F2B"/>
                 </a:solidFill>
@@ -17692,7 +17692,7 @@
               </a:spcAft>
             </a:pPr>
             <a:r>
-              <a:rPr sz="1900" b="1">
+              <a:rPr sz="1500" b="1">
                 <a:solidFill>
                   <a:srgbClr val="FDB515"/>
                 </a:solidFill>
@@ -17701,7 +17701,7 @@
               <a:t>—  </a:t>
             </a:r>
             <a:r>
-              <a:rPr sz="1900" b="1">
+              <a:rPr sz="1500" b="1">
                 <a:solidFill>
                   <a:srgbClr val="003262"/>
                 </a:solidFill>
@@ -17710,7 +17710,7 @@
               <a:t>Three idiomatic uses:  </a:t>
             </a:r>
             <a:r>
-              <a:rPr sz="1900">
+              <a:rPr sz="1500">
                 <a:solidFill>
                   <a:srgbClr val="1A1F2B"/>
                 </a:solidFill>
@@ -17729,7 +17729,7 @@
               </a:spcAft>
             </a:pPr>
             <a:r>
-              <a:rPr sz="1900" b="1">
+              <a:rPr sz="1500" b="1">
                 <a:solidFill>
                   <a:srgbClr val="FDB515"/>
                 </a:solidFill>
@@ -17738,7 +17738,7 @@
               <a:t>—  </a:t>
             </a:r>
             <a:r>
-              <a:rPr sz="1900" b="1">
+              <a:rPr sz="1500" b="1">
                 <a:solidFill>
                   <a:srgbClr val="003262"/>
                 </a:solidFill>
@@ -17747,7 +17747,7 @@
               <a:t>Ensemble disagreement:  </a:t>
             </a:r>
             <a:r>
-              <a:rPr sz="1900">
+              <a:rPr sz="1500">
                 <a:solidFill>
                   <a:srgbClr val="1A1F2B"/>
                 </a:solidFill>
@@ -17766,7 +17766,7 @@
               </a:spcAft>
             </a:pPr>
             <a:r>
-              <a:rPr sz="1900" b="1">
+              <a:rPr sz="1500" b="1">
                 <a:solidFill>
                   <a:srgbClr val="FDB515"/>
                 </a:solidFill>
@@ -17775,7 +17775,7 @@
               <a:t>—  </a:t>
             </a:r>
             <a:r>
-              <a:rPr sz="1900" b="1">
+              <a:rPr sz="1500" b="1">
                 <a:solidFill>
                   <a:srgbClr val="003262"/>
                 </a:solidFill>
@@ -17784,7 +17784,7 @@
               <a:t>Single continuous task:  </a:t>
             </a:r>
             <a:r>
-              <a:rPr sz="1900">
+              <a:rPr sz="1500">
                 <a:solidFill>
                   <a:srgbClr val="1A1F2B"/>
                 </a:solidFill>
@@ -17941,7 +17941,7 @@
               </a:spcAft>
             </a:pPr>
             <a:r>
-              <a:rPr sz="1900" b="0" i="1">
+              <a:rPr sz="1500" b="0" i="1">
                 <a:solidFill>
                   <a:srgbClr val="FFFFFF"/>
                 </a:solidFill>
@@ -25520,7 +25520,7 @@
               </a:spcAft>
             </a:pPr>
             <a:r>
-              <a:rPr sz="1900" b="1">
+              <a:rPr sz="1700" b="1">
                 <a:solidFill>
                   <a:srgbClr val="FDB515"/>
                 </a:solidFill>
@@ -25529,7 +25529,7 @@
               <a:t>—  </a:t>
             </a:r>
             <a:r>
-              <a:rPr sz="1900" b="1">
+              <a:rPr sz="1700" b="1">
                 <a:solidFill>
                   <a:srgbClr val="003262"/>
                 </a:solidFill>
@@ -25538,7 +25538,7 @@
               <a:t>Three-step protocol:  </a:t>
             </a:r>
             <a:r>
-              <a:rPr sz="1900">
+              <a:rPr sz="1700">
                 <a:solidFill>
                   <a:srgbClr val="1A1F2B"/>
                 </a:solidFill>
@@ -25557,7 +25557,7 @@
               </a:spcAft>
             </a:pPr>
             <a:r>
-              <a:rPr sz="1900" b="1">
+              <a:rPr sz="1700" b="1">
                 <a:solidFill>
                   <a:srgbClr val="FDB515"/>
                 </a:solidFill>
@@ -25566,7 +25566,7 @@
               <a:t>—  </a:t>
             </a:r>
             <a:r>
-              <a:rPr sz="1900" b="1">
+              <a:rPr sz="1700" b="1">
                 <a:solidFill>
                   <a:srgbClr val="003262"/>
                 </a:solidFill>
@@ -25575,7 +25575,7 @@
               <a:t>Evidence, not edits:  </a:t>
             </a:r>
             <a:r>
-              <a:rPr sz="1900">
+              <a:rPr sz="1700">
                 <a:solidFill>
                   <a:srgbClr val="1A1F2B"/>
                 </a:solidFill>
@@ -25594,7 +25594,7 @@
               </a:spcAft>
             </a:pPr>
             <a:r>
-              <a:rPr sz="1900" b="1">
+              <a:rPr sz="1700" b="1">
                 <a:solidFill>
                   <a:srgbClr val="FDB515"/>
                 </a:solidFill>
@@ -25603,7 +25603,7 @@
               <a:t>—  </a:t>
             </a:r>
             <a:r>
-              <a:rPr sz="1900" b="1">
+              <a:rPr sz="1700" b="1">
                 <a:solidFill>
                   <a:srgbClr val="003262"/>
                 </a:solidFill>
@@ -25612,7 +25612,7 @@
               <a:t>Concurrency sub-class:  </a:t>
             </a:r>
             <a:r>
-              <a:rPr sz="1900">
+              <a:rPr sz="1700">
                 <a:solidFill>
                   <a:srgbClr val="1A1F2B"/>
                 </a:solidFill>
@@ -25631,7 +25631,7 @@
               </a:spcAft>
             </a:pPr>
             <a:r>
-              <a:rPr sz="1900" b="1">
+              <a:rPr sz="1700" b="1">
                 <a:solidFill>
                   <a:srgbClr val="FDB515"/>
                 </a:solidFill>
@@ -25640,7 +25640,7 @@
               <a:t>—  </a:t>
             </a:r>
             <a:r>
-              <a:rPr sz="1900" b="1">
+              <a:rPr sz="1700" b="1">
                 <a:solidFill>
                   <a:srgbClr val="003262"/>
                 </a:solidFill>
@@ -25649,7 +25649,7 @@
               <a:t>Defensive revert:  </a:t>
             </a:r>
             <a:r>
-              <a:rPr sz="1900">
+              <a:rPr sz="1700">
                 <a:solidFill>
                   <a:srgbClr val="1A1F2B"/>
                 </a:solidFill>
@@ -25806,7 +25806,7 @@
               </a:spcAft>
             </a:pPr>
             <a:r>
-              <a:rPr sz="1900" b="0" i="1">
+              <a:rPr sz="1700" b="0" i="1">
                 <a:solidFill>
                   <a:srgbClr val="FFFFFF"/>
                 </a:solidFill>
@@ -26061,7 +26061,7 @@
               </a:spcAft>
             </a:pPr>
             <a:r>
-              <a:rPr sz="1900" b="1">
+              <a:rPr sz="1700" b="1">
                 <a:solidFill>
                   <a:srgbClr val="FDB515"/>
                 </a:solidFill>
@@ -26070,7 +26070,7 @@
               <a:t>—  </a:t>
             </a:r>
             <a:r>
-              <a:rPr sz="1900" b="1">
+              <a:rPr sz="1700" b="1">
                 <a:solidFill>
                   <a:srgbClr val="003262"/>
                 </a:solidFill>
@@ -26079,7 +26079,7 @@
               <a:t>Remote web server:  </a:t>
             </a:r>
             <a:r>
-              <a:rPr sz="1900">
+              <a:rPr sz="1700">
                 <a:solidFill>
                   <a:srgbClr val="1A1F2B"/>
                 </a:solidFill>
@@ -26098,7 +26098,7 @@
               </a:spcAft>
             </a:pPr>
             <a:r>
-              <a:rPr sz="1900" b="1">
+              <a:rPr sz="1700" b="1">
                 <a:solidFill>
                   <a:srgbClr val="FDB515"/>
                 </a:solidFill>
@@ -26107,7 +26107,7 @@
               <a:t>—  </a:t>
             </a:r>
             <a:r>
-              <a:rPr sz="1900" b="1">
+              <a:rPr sz="1700" b="1">
                 <a:solidFill>
                   <a:srgbClr val="003262"/>
                 </a:solidFill>
@@ -26116,7 +26116,7 @@
               <a:t>Spec emerges from use:  </a:t>
             </a:r>
             <a:r>
-              <a:rPr sz="1900">
+              <a:rPr sz="1700">
                 <a:solidFill>
                   <a:srgbClr val="1A1F2B"/>
                 </a:solidFill>
@@ -26135,7 +26135,7 @@
               </a:spcAft>
             </a:pPr>
             <a:r>
-              <a:rPr sz="1900" b="1">
+              <a:rPr sz="1700" b="1">
                 <a:solidFill>
                   <a:srgbClr val="FDB515"/>
                 </a:solidFill>
@@ -26144,7 +26144,7 @@
               <a:t>—  </a:t>
             </a:r>
             <a:r>
-              <a:rPr sz="1900" b="1">
+              <a:rPr sz="1700" b="1">
                 <a:solidFill>
                   <a:srgbClr val="003262"/>
                 </a:solidFill>
@@ -26153,7 +26153,7 @@
               <a:t>Interleaved with fixing:  </a:t>
             </a:r>
             <a:r>
-              <a:rPr sz="1900">
+              <a:rPr sz="1700">
                 <a:solidFill>
                   <a:srgbClr val="1A1F2B"/>
                 </a:solidFill>
@@ -26172,7 +26172,7 @@
               </a:spcAft>
             </a:pPr>
             <a:r>
-              <a:rPr sz="1900" b="1">
+              <a:rPr sz="1700" b="1">
                 <a:solidFill>
                   <a:srgbClr val="FDB515"/>
                 </a:solidFill>
@@ -26181,7 +26181,7 @@
               <a:t>—  </a:t>
             </a:r>
             <a:r>
-              <a:rPr sz="1900" b="1">
+              <a:rPr sz="1700" b="1">
                 <a:solidFill>
                   <a:srgbClr val="003262"/>
                 </a:solidFill>
@@ -26190,7 +26190,7 @@
               <a:t>Demo mode:  </a:t>
             </a:r>
             <a:r>
-              <a:rPr sz="1900">
+              <a:rPr sz="1700">
                 <a:solidFill>
                   <a:srgbClr val="1A1F2B"/>
                 </a:solidFill>
@@ -26347,7 +26347,7 @@
               </a:spcAft>
             </a:pPr>
             <a:r>
-              <a:rPr sz="1900" b="0" i="1">
+              <a:rPr sz="1700" b="0" i="1">
                 <a:solidFill>
                   <a:srgbClr val="FFFFFF"/>
                 </a:solidFill>

</xml_diff>